<commit_message>
docs: deck v2, add step 5 (reranking) slide and update roadmap, decision log, plan
Co-Authored-By: Claude Opus 5.5 <noreply@anthropic.com>
</commit_message>
<xml_diff>
--- a/docs/status/project-roadmap-v2.pptx
+++ b/docs/status/project-roadmap-v2.pptx
@@ -19,9 +19,10 @@
     <p:sldId id="267" r:id="rId13"/>
     <p:sldId id="268" r:id="rId14"/>
     <p:sldId id="269" r:id="rId15"/>
+    <p:sldId id="270" r:id="rId16"/>
   </p:sldIdLst>
   <p:notesMasterIdLst>
-    <p:notesMasterId r:id="rId16"/>
+    <p:notesMasterId r:id="rId17"/>
   </p:notesMasterIdLst>
   <p:sldSz cx="12192000" cy="6858000"/>
   <p:notesSz cx="6858000" cy="12192000"/>
@@ -120,14 +121,14 @@
   <p:extLst>
     <p:ext uri="{521415D9-36F7-43E2-AB2F-B90AF26B5E84}">
       <p14:sectionLst xmlns:p14="http://schemas.microsoft.com/office/powerpoint/2010/main">
-        <p14:section name="Roadmap" id="{cf7684ac-8fd4-11da-bf67-9b5808ea4fd1}">
+        <p14:section name="Roadmap" id="{56a8caa7-e2fd-c958-590c-738972db7bae}">
           <p14:sldIdLst>
             <p14:sldId id="256"/>
             <p14:sldId id="257"/>
             <p14:sldId id="258"/>
           </p14:sldIdLst>
         </p14:section>
-        <p14:section name="Phase 2" id="{2a44e333-f283-656a-9606-e9b19ddb712c}">
+        <p14:section name="Phase 2" id="{d471b4b6-f28c-cab0-2c36-ce09417d00bd}">
           <p14:sldIdLst>
             <p14:sldId id="259"/>
             <p14:sldId id="260"/>
@@ -140,6 +141,7 @@
             <p14:sldId id="267"/>
             <p14:sldId id="268"/>
             <p14:sldId id="269"/>
+            <p14:sldId id="270"/>
           </p14:sldIdLst>
         </p14:section>
       </p14:sectionLst>
@@ -1698,6 +1700,389 @@
 </c:chartSpace>
 </file>
 
+<file path=ppt/charts/chart5.xml><?xml version="1.0" encoding="utf-8"?>
+<c:chartSpace xmlns:c="http://schemas.openxmlformats.org/drawingml/2006/chart" xmlns:a="http://schemas.openxmlformats.org/drawingml/2006/main" xmlns:r="http://schemas.openxmlformats.org/officeDocument/2006/relationships">
+  <c:date1904 val="0"/>
+  <c:roundedCorners val="1"/>
+  <c:chart>
+    <c:title>
+      <c:tx>
+        <c:rich>
+          <a:bodyPr/>
+          <a:lstStyle/>
+          <a:p>
+            <a:pPr>
+              <a:defRPr sz="1400" b="0" i="0" u="none" strike="noStrike">
+                <a:solidFill>
+                  <a:srgbClr val="1B2333"/>
+                </a:solidFill>
+                <a:latin typeface="+mn-lt"/>
+              </a:defRPr>
+            </a:pPr>
+            <a:r>
+              <a:rPr sz="1400" b="0" i="0" u="none" strike="noStrike">
+                <a:solidFill>
+                  <a:srgbClr val="1B2333"/>
+                </a:solidFill>
+                <a:latin typeface="+mn-lt"/>
+              </a:rPr>
+              <a:t>Right aid ranked 1st</a:t>
+            </a:r>
+          </a:p>
+        </c:rich>
+      </c:tx>
+      <c:layout/>
+      <c:overlay val="0"/>
+    </c:title>
+    <c:autoTitleDeleted val="0"/>
+    <c:plotArea>
+      <c:layout/>
+      <c:barChart>
+        <c:barDir val="col"/>
+        <c:grouping val="clustered"/>
+        <c:varyColors val="0"/>
+        <c:ser>
+          <c:idx val="0"/>
+          <c:order val="0"/>
+          <c:tx>
+            <c:strRef>
+              <c:f>Sheet1!$B$1</c:f>
+              <c:strCache>
+                <c:ptCount val="1"/>
+                <c:pt idx="0">
+                  <c:v>Dev</c:v>
+                </c:pt>
+              </c:strCache>
+            </c:strRef>
+          </c:tx>
+          <c:spPr>
+            <a:solidFill>
+              <a:srgbClr val="2F5BD3"/>
+            </a:solidFill>
+            <a:effectLst/>
+          </c:spPr>
+          <c:invertIfNegative val="0"/>
+          <c:dLbls>
+            <c:numFmt formatCode="0&quot;%&quot;" sourceLinked="0"/>
+            <c:txPr>
+              <a:bodyPr/>
+              <a:lstStyle/>
+              <a:p>
+                <a:pPr>
+                  <a:defRPr b="0" i="0" strike="noStrike" sz="1100" u="none">
+                    <a:solidFill>
+                      <a:srgbClr val="1B2333"/>
+                    </a:solidFill>
+                    <a:latin typeface="+mn-lt"/>
+                  </a:defRPr>
+                </a:pPr>
+              </a:p>
+            </c:txPr>
+            <c:showLegendKey val="0"/>
+            <c:showVal val="1"/>
+            <c:showCatName val="0"/>
+            <c:showSerName val="0"/>
+            <c:showPercent val="0"/>
+            <c:showBubbleSize val="0"/>
+            <c:showLeaderLines val="0"/>
+          </c:dLbls>
+          <c:cat>
+            <c:multiLvlStrRef>
+              <c:f>Sheet1!$A$2:$A$5</c:f>
+              <c:multiLvlStrCache>
+                <c:ptCount val="4"/>
+                <c:lvl>
+                  <c:pt idx="0">
+                    <c:v>Hybrid, equal weights</c:v>
+                  </c:pt>
+                  <c:pt idx="1">
+                    <c:v>+ mMiniLM reranker</c:v>
+                  </c:pt>
+                  <c:pt idx="2">
+                    <c:v>+ bge-reranker</c:v>
+                  </c:pt>
+                  <c:pt idx="3">
+                    <c:v>Hybrid, meaning ×3</c:v>
+                  </c:pt>
+                </c:lvl>
+              </c:multiLvlStrCache>
+            </c:multiLvlStrRef>
+          </c:cat>
+          <c:val>
+            <c:numRef>
+              <c:f>Sheet1!$B$2:$B$5</c:f>
+              <c:numCache>
+                <c:formatCode>General</c:formatCode>
+                <c:ptCount val="4"/>
+                <c:pt idx="0">
+                  <c:v>85.3</c:v>
+                </c:pt>
+                <c:pt idx="1">
+                  <c:v>85.3</c:v>
+                </c:pt>
+                <c:pt idx="2">
+                  <c:v>91.2</c:v>
+                </c:pt>
+                <c:pt idx="3">
+                  <c:v>91.2</c:v>
+                </c:pt>
+              </c:numCache>
+            </c:numRef>
+          </c:val>
+        </c:ser>
+        <c:ser>
+          <c:idx val="1"/>
+          <c:order val="1"/>
+          <c:tx>
+            <c:strRef>
+              <c:f>Sheet1!$C$1</c:f>
+              <c:strCache>
+                <c:ptCount val="1"/>
+                <c:pt idx="0">
+                  <c:v>Held-out</c:v>
+                </c:pt>
+              </c:strCache>
+            </c:strRef>
+          </c:tx>
+          <c:spPr>
+            <a:solidFill>
+              <a:srgbClr val="D0518F"/>
+            </a:solidFill>
+            <a:effectLst/>
+          </c:spPr>
+          <c:invertIfNegative val="0"/>
+          <c:dLbls>
+            <c:numFmt formatCode="0&quot;%&quot;" sourceLinked="0"/>
+            <c:txPr>
+              <a:bodyPr/>
+              <a:lstStyle/>
+              <a:p>
+                <a:pPr>
+                  <a:defRPr b="0" i="0" strike="noStrike" sz="1100" u="none">
+                    <a:solidFill>
+                      <a:srgbClr val="1B2333"/>
+                    </a:solidFill>
+                    <a:latin typeface="+mn-lt"/>
+                  </a:defRPr>
+                </a:pPr>
+              </a:p>
+            </c:txPr>
+            <c:showLegendKey val="0"/>
+            <c:showVal val="1"/>
+            <c:showCatName val="0"/>
+            <c:showSerName val="0"/>
+            <c:showPercent val="0"/>
+            <c:showBubbleSize val="0"/>
+            <c:showLeaderLines val="0"/>
+          </c:dLbls>
+          <c:cat>
+            <c:multiLvlStrRef>
+              <c:f>Sheet1!$A$2:$A$5</c:f>
+              <c:multiLvlStrCache>
+                <c:ptCount val="4"/>
+                <c:lvl>
+                  <c:pt idx="0">
+                    <c:v>Hybrid, equal weights</c:v>
+                  </c:pt>
+                  <c:pt idx="1">
+                    <c:v>+ mMiniLM reranker</c:v>
+                  </c:pt>
+                  <c:pt idx="2">
+                    <c:v>+ bge-reranker</c:v>
+                  </c:pt>
+                  <c:pt idx="3">
+                    <c:v>Hybrid, meaning ×3</c:v>
+                  </c:pt>
+                </c:lvl>
+              </c:multiLvlStrCache>
+            </c:multiLvlStrRef>
+          </c:cat>
+          <c:val>
+            <c:numRef>
+              <c:f>Sheet1!$C$2:$C$5</c:f>
+              <c:numCache>
+                <c:formatCode>General</c:formatCode>
+                <c:ptCount val="4"/>
+                <c:pt idx="0">
+                  <c:v>75</c:v>
+                </c:pt>
+                <c:pt idx="1">
+                  <c:v>50</c:v>
+                </c:pt>
+                <c:pt idx="2">
+                  <c:v>75</c:v>
+                </c:pt>
+                <c:pt idx="3">
+                  <c:v>87.5</c:v>
+                </c:pt>
+              </c:numCache>
+            </c:numRef>
+          </c:val>
+        </c:ser>
+        <c:dLbls>
+          <c:numFmt formatCode="0&quot;%&quot;" sourceLinked="0"/>
+          <c:txPr>
+            <a:bodyPr/>
+            <a:lstStyle/>
+            <a:p>
+              <a:pPr>
+                <a:defRPr b="0" i="0" strike="noStrike" sz="1100" u="none">
+                  <a:solidFill>
+                    <a:srgbClr val="1B2333"/>
+                  </a:solidFill>
+                  <a:latin typeface="+mn-lt"/>
+                </a:defRPr>
+              </a:pPr>
+            </a:p>
+          </c:txPr>
+          <c:showLegendKey val="0"/>
+          <c:showVal val="1"/>
+          <c:showCatName val="0"/>
+          <c:showSerName val="0"/>
+          <c:showPercent val="0"/>
+          <c:showBubbleSize val="0"/>
+          <c:showLeaderLines val="0"/>
+        </c:dLbls>
+        <c:gapWidth val="55"/>
+        <c:overlap val="0"/>
+        <c:axId val="2094734554"/>
+        <c:axId val="2094734552"/>
+        <c:axId val="2094734556"/>
+      </c:barChart>
+      <c:catAx>
+        <c:axId val="2094734554"/>
+        <c:scaling>
+          <c:orientation val="minMax"/>
+        </c:scaling>
+        <c:delete val="0"/>
+        <c:axPos val="b"/>
+        <c:numFmt formatCode="General" sourceLinked="1"/>
+        <c:majorTickMark val="out"/>
+        <c:minorTickMark val="none"/>
+        <c:tickLblPos val="low"/>
+        <c:spPr>
+          <a:ln w="12700" cap="flat">
+            <a:noFill/>
+            <a:prstDash val="solid"/>
+            <a:round/>
+          </a:ln>
+        </c:spPr>
+        <c:txPr>
+          <a:bodyPr/>
+          <a:lstStyle/>
+          <a:p>
+            <a:pPr>
+              <a:defRPr sz="1200" b="0" i="0" u="none" strike="noStrike">
+                <a:solidFill>
+                  <a:srgbClr val="5D6470"/>
+                </a:solidFill>
+                <a:latin typeface="+mn-lt"/>
+              </a:defRPr>
+            </a:pPr>
+            <a:endParaRPr lang="en-US"/>
+          </a:p>
+        </c:txPr>
+        <c:crossAx val="2094734552"/>
+        <c:crosses val="autoZero"/>
+        <c:auto val="1"/>
+        <c:lblAlgn val="ctr"/>
+        <c:noMultiLvlLbl val="1"/>
+      </c:catAx>
+      <c:valAx>
+        <c:axId val="2094734552"/>
+        <c:scaling>
+          <c:orientation val="minMax"/>
+          <c:max val="112"/>
+          <c:min val="0"/>
+        </c:scaling>
+        <c:delete val="0"/>
+        <c:axPos val="l"/>
+        <c:majorGridlines>
+          <c:spPr>
+            <a:ln w="9525" cap="flat">
+              <a:solidFill>
+                <a:srgbClr val="E3E6EC"/>
+              </a:solidFill>
+              <a:prstDash val="solid"/>
+              <a:round/>
+            </a:ln>
+          </c:spPr>
+        </c:majorGridlines>
+        <c:numFmt formatCode="0&quot;%&quot;" sourceLinked="0"/>
+        <c:majorTickMark val="out"/>
+        <c:minorTickMark val="none"/>
+        <c:tickLblPos val="nextTo"/>
+        <c:spPr>
+          <a:ln w="12700" cap="flat">
+            <a:noFill/>
+            <a:prstDash val="solid"/>
+            <a:round/>
+          </a:ln>
+        </c:spPr>
+        <c:txPr>
+          <a:bodyPr/>
+          <a:lstStyle/>
+          <a:p>
+            <a:pPr>
+              <a:defRPr sz="1100" b="0" i="0" u="none" strike="noStrike">
+                <a:solidFill>
+                  <a:srgbClr val="5D6470"/>
+                </a:solidFill>
+                <a:latin typeface="+mn-lt"/>
+              </a:defRPr>
+            </a:pPr>
+            <a:endParaRPr lang="en-US"/>
+          </a:p>
+        </c:txPr>
+        <c:crossAx val="2094734554"/>
+        <c:crosses val="autoZero"/>
+        <c:crossBetween val="between"/>
+        <c:majorUnit val="25"/>
+      </c:valAx>
+      <c:spPr>
+        <a:noFill/>
+        <a:ln>
+          <a:noFill/>
+        </a:ln>
+        <a:effectLst/>
+      </c:spPr>
+    </c:plotArea>
+    <c:legend>
+      <c:legendPos val="b"/>
+      <c:overlay val="0"/>
+      <c:txPr>
+        <a:bodyPr/>
+        <a:lstStyle/>
+        <a:p>
+          <a:pPr>
+            <a:defRPr sz="1200">
+              <a:solidFill>
+                <a:srgbClr val="1B2333"/>
+              </a:solidFill>
+              <a:latin typeface="+mn-lt"/>
+              <a:cs typeface="+mn-lt"/>
+            </a:defRPr>
+          </a:pPr>
+          <a:endParaRPr lang="en-US"/>
+        </a:p>
+      </c:txPr>
+    </c:legend>
+    <c:plotVisOnly val="1"/>
+    <c:dispBlanksAs val="span"/>
+  </c:chart>
+  <c:spPr>
+    <a:noFill/>
+    <a:ln>
+      <a:noFill/>
+    </a:ln>
+    <a:effectLst/>
+  </c:spPr>
+  <c:externalData r:id="rId1">
+    <c:autoUpdate val="0"/>
+  </c:externalData>
+</c:chartSpace>
+</file>
+
 <file path=ppt/notesMasters/notesMaster1.xml><?xml version="1.0" encoding="utf-8"?>
 <p:notesMaster xmlns:a="http://schemas.openxmlformats.org/drawingml/2006/main" xmlns:r="http://schemas.openxmlformats.org/officeDocument/2006/relationships" xmlns:p="http://schemas.openxmlformats.org/presentationml/2006/main">
   <p:cSld>
@@ -2357,7 +2742,7 @@
           <a:p>
             <a:r>
               <a:rPr lang="en-US" dirty="0"/>
-              <a:t>This is the list to rehearse for the Q&amp;A: each choice has either a measurement or a rule from the brief behind it.</a:t>
+              <a:t>We tested two cross-encoder rerankers. The small one made rank 1 worse; the strong one helped one dev question, nothing on held-out, and costs 19 seconds per question on this CPU. A free setting does better: in the merge, meaning search counts three times more than keyword search. Held-out rank 1 goes from 75 to 88 percent. The strong reranker stays in the code as an option.</a:t>
             </a:r>
             <a:endParaRPr lang="en-US" dirty="0"/>
           </a:p>
@@ -2445,7 +2830,7 @@
           <a:p>
             <a:r>
               <a:rPr lang="en-US" dirty="0"/>
-              <a:t>Eight pull requests so far, seven merged. Three lessons: always get one approval before merging; run the checks again after each merge, because two good PRs can clash; and delete branches once merged.</a:t>
+              <a:t>This is the list to rehearse for the Q&amp;A: each choice has either a measurement or a rule from the brief behind it.</a:t>
             </a:r>
             <a:endParaRPr lang="en-US" dirty="0"/>
           </a:p>
@@ -2533,7 +2918,7 @@
           <a:p>
             <a:r>
               <a:rPr lang="en-US" dirty="0"/>
-              <a:t>Fill the owner column together. The critical path is reranker, then answering model, then agent tools, then final scores. Keep Tuesday for polish and the backup demo video only.</a:t>
+              <a:t>Eight pull requests so far, seven merged. Three lessons: always get one approval before merging; run the checks again after each merge, because two good PRs can clash; and delete branches once merged.</a:t>
             </a:r>
             <a:endParaRPr lang="en-US" dirty="0"/>
           </a:p>
@@ -2557,6 +2942,94 @@
             <a:fld id="{F7021451-1387-4CA6-816F-3879F97B5CBC}" type="slidenum">
               <a:rPr lang="en-US"/>
               <a:t>14</a:t>
+            </a:fld>
+            <a:endParaRPr lang="en-US"/>
+          </a:p>
+        </p:txBody>
+      </p:sp>
+    </p:spTree>
+    <p:extLst>
+      <p:ext uri="{BB962C8B-B14F-4D97-AF65-F5344CB8AC3E}">
+        <p14:creationId xmlns:p14="http://schemas.microsoft.com/office/powerpoint/2010/main" val="1024086991"/>
+      </p:ext>
+    </p:extLst>
+  </p:cSld>
+  <p:clrMapOvr>
+    <a:masterClrMapping/>
+  </p:clrMapOvr>
+</p:notes>
+</file>
+
+<file path=ppt/notesSlides/notesSlide15.xml><?xml version="1.0" encoding="utf-8"?>
+<p:notes xmlns:a="http://schemas.openxmlformats.org/drawingml/2006/main" xmlns:r="http://schemas.openxmlformats.org/officeDocument/2006/relationships" xmlns:p="http://schemas.openxmlformats.org/presentationml/2006/main">
+  <p:cSld>
+    <p:spTree>
+      <p:nvGrpSpPr>
+        <p:cNvPr id="1" name=""/>
+        <p:cNvGrpSpPr/>
+        <p:nvPr/>
+      </p:nvGrpSpPr>
+      <p:grpSpPr>
+        <a:xfrm>
+          <a:off x="0" y="0"/>
+          <a:ext cx="0" cy="0"/>
+          <a:chOff x="0" y="0"/>
+          <a:chExt cx="0" cy="0"/>
+        </a:xfrm>
+      </p:grpSpPr>
+      <p:sp>
+        <p:nvSpPr>
+          <p:cNvPr id="2" name="Slide Image Placeholder 1"/>
+          <p:cNvSpPr>
+            <a:spLocks noGrp="1" noRot="1" noChangeAspect="1"/>
+          </p:cNvSpPr>
+          <p:nvPr>
+            <p:ph type="sldImg"/>
+          </p:nvPr>
+        </p:nvSpPr>
+        <p:spPr/>
+      </p:sp>
+      <p:sp>
+        <p:nvSpPr>
+          <p:cNvPr id="3" name="Notes Placeholder 2"/>
+          <p:cNvSpPr>
+            <a:spLocks noGrp="1"/>
+          </p:cNvSpPr>
+          <p:nvPr>
+            <p:ph type="body" idx="1"/>
+          </p:nvPr>
+        </p:nvSpPr>
+        <p:spPr/>
+        <p:txBody>
+          <a:bodyPr/>
+          <a:lstStyle/>
+          <a:p>
+            <a:r>
+              <a:rPr lang="en-US" dirty="0"/>
+              <a:t>Fill the owner column together. The critical path is reranker, then answering model, then agent tools, then final scores. Keep Tuesday for polish and the backup demo video only.</a:t>
+            </a:r>
+            <a:endParaRPr lang="en-US" dirty="0"/>
+          </a:p>
+        </p:txBody>
+      </p:sp>
+      <p:sp>
+        <p:nvSpPr>
+          <p:cNvPr id="4" name="Slide Number Placeholder 3"/>
+          <p:cNvSpPr>
+            <a:spLocks noGrp="1"/>
+          </p:cNvSpPr>
+          <p:nvPr>
+            <p:ph type="sldNum" sz="quarter" idx="10"/>
+          </p:nvPr>
+        </p:nvSpPr>
+        <p:spPr/>
+        <p:txBody>
+          <a:bodyPr/>
+          <a:lstStyle/>
+          <a:p>
+            <a:fld id="{F7021451-1387-4CA6-816F-3879F97B5CBC}" type="slidenum">
+              <a:rPr lang="en-US"/>
+              <a:t>15</a:t>
             </a:fld>
             <a:endParaRPr lang="en-US"/>
           </a:p>
@@ -3779,7 +4252,7 @@
                   <a:schemeClr val="tx2"/>
                 </a:solidFill>
               </a:rPr>
-              <a:t>Roadmap: 4 of 12 steps done, 4 days to code freeze</a:t>
+              <a:t>Roadmap: 4 steps done, 2 in review, 4 days to freeze</a:t>
             </a:r>
             <a:endParaRPr lang="en-US" sz="3000" dirty="0"/>
           </a:p>
@@ -3815,7 +4288,7 @@
                   <a:schemeClr val="accent6"/>
                 </a:solidFill>
               </a:rPr>
-              <a:t>RAG assistant on French green &amp; innovation business aids · status as of Fri 16 Oct 2026</a:t>
+              <a:t>RAG assistant on French green &amp; innovation business aids · status as of Sat 17 Oct 2026</a:t>
             </a:r>
             <a:endParaRPr lang="en-US" sz="1400" dirty="0"/>
           </a:p>
@@ -4926,7 +5399,7 @@
                   <a:schemeClr val="tx1"/>
                 </a:solidFill>
               </a:rPr>
-              <a:t>Reranker</a:t>
+              <a:t>Ranking + reranker</a:t>
             </a:r>
             <a:endParaRPr lang="en-US" sz="1150" dirty="0"/>
           </a:p>
@@ -5738,7 +6211,7 @@
         </p:nvSpPr>
         <p:spPr>
           <a:xfrm>
-            <a:off x="5263619" y="1892808"/>
+            <a:off x="5733288" y="1892808"/>
             <a:ext cx="694944" cy="219456"/>
           </a:xfrm>
           <a:prstGeom prst="roundRect">
@@ -5765,7 +6238,7 @@
         </p:nvSpPr>
         <p:spPr>
           <a:xfrm>
-            <a:off x="5263619" y="1892808"/>
+            <a:off x="5733288" y="1892808"/>
             <a:ext cx="694944" cy="219456"/>
           </a:xfrm>
           <a:prstGeom prst="rect">
@@ -5859,7 +6332,7 @@
                   <a:schemeClr val="accent6"/>
                 </a:solidFill>
               </a:rPr>
-              <a:t>code ready</a:t>
+              <a:t>PR #8 in review</a:t>
             </a:r>
             <a:endParaRPr lang="en-US" sz="1000" dirty="0"/>
           </a:p>
@@ -6023,7 +6496,7 @@
                   <a:schemeClr val="tx1"/>
                 </a:solidFill>
               </a:rPr>
-              <a:t>3 meaning-search models tested; bge-m3 chosen</a:t>
+              <a:t>bge-m3 chosen; 2 rerankers tested; free ×3 fix adopted</a:t>
             </a:r>
             <a:endParaRPr lang="en-US" sz="1400" dirty="0"/>
           </a:p>
@@ -6151,7 +6624,7 @@
                   <a:schemeClr val="tx1"/>
                 </a:solidFill>
               </a:rPr>
-              <a:t>Run the reranker benchmark, then review PR #8</a:t>
+              <a:t>Review and merge PR #8 (search + ranking)</a:t>
             </a:r>
             <a:endParaRPr lang="en-US" sz="1400" dirty="0"/>
           </a:p>
@@ -6315,7 +6788,7 @@
                   <a:schemeClr val="tx1"/>
                 </a:solidFill>
               </a:rPr>
-              <a:t>Who owns which step from Sat to Tue (slide 14)</a:t>
+              <a:t>Who owns which step from Sat to Tue (slide 15)</a:t>
             </a:r>
             <a:endParaRPr lang="en-US" sz="1400" dirty="0"/>
           </a:p>
@@ -6387,7 +6860,7 @@
                   <a:schemeClr val="accent6"/>
                 </a:solidFill>
               </a:rPr>
-              <a:t>Source: repo and GitHub, 16 Oct 2026. Dates are targets; owners per step to be agreed at the meeting.</a:t>
+              <a:t>Source: repo and GitHub, 17 Oct 2026. Dates are targets; owners per step to be agreed at the meeting.</a:t>
             </a:r>
             <a:endParaRPr lang="en-US" sz="1000" dirty="0"/>
           </a:p>
@@ -7763,7 +8236,7 @@
                   <a:schemeClr val="accent6"/>
                 </a:solidFill>
               </a:rPr>
-              <a:t>1) Merging keyword + meaning lowers rank 1, so the reranker must fix the order. 2) A lead for “I don't know”.</a:t>
+              <a:t>1) Merging keyword + meaning lowered rank 1 (fixed in step 5, next slide). 2) A lead for “I don't know”.</a:t>
             </a:r>
             <a:endParaRPr lang="en-US" sz="1400" dirty="0"/>
           </a:p>
@@ -7815,7 +8288,7 @@
                   <a:schemeClr val="tx1"/>
                 </a:solidFill>
               </a:rPr>
-              <a:t>Keyword search pushes wrong aids up when merged. Next step: the reranker re-reads the top candidates and re-sorts them.</a:t>
+              <a:t>Keyword search pushes wrong aids up when both count equally. Step 5 tests rerankers and a cheaper fix.</a:t>
             </a:r>
             <a:endParaRPr lang="en-US" sz="1300" dirty="0"/>
           </a:p>
@@ -8204,6 +8677,793 @@
                   <a:schemeClr val="tx2"/>
                 </a:solidFill>
               </a:rPr>
+              <a:t>Step 5 · Reranking tested: a free setting wins</a:t>
+            </a:r>
+            <a:endParaRPr lang="en-US" sz="3000" dirty="0"/>
+          </a:p>
+        </p:txBody>
+      </p:sp>
+      <p:sp>
+        <p:nvSpPr>
+          <p:cNvPr id="3" name="Rerank subtitle"/>
+          <p:cNvSpPr txBox="1"/>
+          <p:nvPr/>
+        </p:nvSpPr>
+        <p:spPr>
+          <a:xfrm>
+            <a:off x="548640" y="1005840"/>
+            <a:ext cx="11064240" cy="320040"/>
+          </a:xfrm>
+          <a:prstGeom prst="rect">
+            <a:avLst/>
+          </a:prstGeom>
+          <a:noFill/>
+          <a:ln/>
+        </p:spPr>
+        <p:txBody>
+          <a:bodyPr wrap="square" lIns="0" tIns="0" rIns="0" bIns="0" rtlCol="0" anchor="ctr"/>
+          <a:lstStyle/>
+          <a:p>
+            <a:pPr indent="0" marL="0">
+              <a:buNone/>
+            </a:pPr>
+            <a:r>
+              <a:rPr lang="en-US" sz="1400" dirty="0">
+                <a:solidFill>
+                  <a:schemeClr val="accent6"/>
+                </a:solidFill>
+              </a:rPr>
+              <a:t>A reranker re-reads question + candidate side by side. We measured 2 rerankers and 1 free setting that needs no model</a:t>
+            </a:r>
+            <a:endParaRPr lang="en-US" sz="1400" dirty="0"/>
+          </a:p>
+        </p:txBody>
+      </p:sp>
+      <p:graphicFrame>
+        <p:nvGraphicFramePr>
+          <p:cNvPr id="4" name="Rerank chart" descr=""/>
+          <p:cNvGraphicFramePr/>
+          <p:nvPr/>
+        </p:nvGraphicFramePr>
+        <p:xfrm>
+          <a:off x="548640" y="1508760"/>
+          <a:ext cx="6583680" cy="4206240"/>
+        </p:xfrm>
+        <a:graphic xmlns:a="http://schemas.openxmlformats.org/drawingml/2006/main">
+          <a:graphicData uri="http://schemas.openxmlformats.org/drawingml/2006/chart">
+            <c:chart xmlns:c="http://schemas.openxmlformats.org/drawingml/2006/chart" r:id="rId1"/>
+          </a:graphicData>
+        </a:graphic>
+      </p:graphicFrame>
+      <p:graphicFrame>
+        <p:nvGraphicFramePr>
+          <p:cNvPr id="13" name="Rerank table"/>
+          <p:cNvGraphicFramePr>
+            <a:graphicFrameLocks noGrp="1"/>
+          </p:cNvGraphicFramePr>
+          <p:nvPr>
+            <p:extLst>
+              <p:ext uri="{D42A27DB-BD31-4B8C-83A1-F6EECF244321}">
+                <p14:modId xmlns:p14="http://schemas.microsoft.com/office/powerpoint/2010/main" val="1579011935"/>
+              </p:ext>
+            </p:extLst>
+          </p:nvPr>
+        </p:nvGraphicFramePr>
+        <p:xfrm>
+          <a:off x="7452360" y="1600200"/>
+          <a:ext cx="4206240" cy="914400"/>
+        </p:xfrm>
+        <a:graphic>
+          <a:graphicData uri="http://schemas.openxmlformats.org/drawingml/2006/table">
+            <a:tbl>
+              <a:tblPr/>
+              <a:tblGrid>
+                <a:gridCol w="2651760"/>
+                <a:gridCol w="1554480"/>
+              </a:tblGrid>
+              <a:tr h="384048">
+                <a:tc>
+                  <a:txBody>
+                    <a:bodyPr/>
+                    <a:lstStyle/>
+                    <a:p>
+                      <a:pPr indent="0" marL="0">
+                        <a:buNone/>
+                      </a:pPr>
+                      <a:r>
+                        <a:rPr lang="en-US" sz="1300" b="1" dirty="0">
+                          <a:solidFill>
+                            <a:schemeClr val="bg1"/>
+                          </a:solidFill>
+                        </a:rPr>
+                        <a:t>Option</a:t>
+                      </a:r>
+                      <a:endParaRPr lang="en-US" sz="1300" dirty="0"/>
+                    </a:p>
+                  </a:txBody>
+                  <a:tcPr marL="54864" marR="54864" marT="54864" marB="54864" anchor="ctr">
+                    <a:lnL w="9525" cap="flat" cmpd="sng" algn="ctr">
+                      <a:solidFill>
+                        <a:srgbClr val="D5DAE1"/>
+                      </a:solidFill>
+                      <a:prstDash val="solid"/>
+                      <a:round/>
+                      <a:headEnd type="none" w="med" len="med"/>
+                      <a:tailEnd type="none" w="med" len="med"/>
+                    </a:lnL>
+                    <a:lnR w="9525" cap="flat" cmpd="sng" algn="ctr">
+                      <a:solidFill>
+                        <a:srgbClr val="D5DAE1"/>
+                      </a:solidFill>
+                      <a:prstDash val="solid"/>
+                      <a:round/>
+                      <a:headEnd type="none" w="med" len="med"/>
+                      <a:tailEnd type="none" w="med" len="med"/>
+                    </a:lnR>
+                    <a:lnT w="9525" cap="flat" cmpd="sng" algn="ctr">
+                      <a:solidFill>
+                        <a:srgbClr val="D5DAE1"/>
+                      </a:solidFill>
+                      <a:prstDash val="solid"/>
+                      <a:round/>
+                      <a:headEnd type="none" w="med" len="med"/>
+                      <a:tailEnd type="none" w="med" len="med"/>
+                    </a:lnT>
+                    <a:lnB w="9525" cap="flat" cmpd="sng" algn="ctr">
+                      <a:solidFill>
+                        <a:srgbClr val="D5DAE1"/>
+                      </a:solidFill>
+                      <a:prstDash val="solid"/>
+                      <a:round/>
+                      <a:headEnd type="none" w="med" len="med"/>
+                      <a:tailEnd type="none" w="med" len="med"/>
+                    </a:lnB>
+                    <a:solidFill>
+                      <a:schemeClr val="tx2"/>
+                    </a:solidFill>
+                  </a:tcPr>
+                </a:tc>
+                <a:tc>
+                  <a:txBody>
+                    <a:bodyPr/>
+                    <a:lstStyle/>
+                    <a:p>
+                      <a:pPr indent="0" marL="0">
+                        <a:buNone/>
+                      </a:pPr>
+                      <a:r>
+                        <a:rPr lang="en-US" sz="1300" b="1" dirty="0">
+                          <a:solidFill>
+                            <a:schemeClr val="bg1"/>
+                          </a:solidFill>
+                        </a:rPr>
+                        <a:t>Extra time / question</a:t>
+                      </a:r>
+                      <a:endParaRPr lang="en-US" sz="1300" dirty="0"/>
+                    </a:p>
+                  </a:txBody>
+                  <a:tcPr marL="54864" marR="54864" marT="54864" marB="54864" anchor="ctr">
+                    <a:lnL w="9525" cap="flat" cmpd="sng" algn="ctr">
+                      <a:solidFill>
+                        <a:srgbClr val="D5DAE1"/>
+                      </a:solidFill>
+                      <a:prstDash val="solid"/>
+                      <a:round/>
+                      <a:headEnd type="none" w="med" len="med"/>
+                      <a:tailEnd type="none" w="med" len="med"/>
+                    </a:lnL>
+                    <a:lnR w="9525" cap="flat" cmpd="sng" algn="ctr">
+                      <a:solidFill>
+                        <a:srgbClr val="D5DAE1"/>
+                      </a:solidFill>
+                      <a:prstDash val="solid"/>
+                      <a:round/>
+                      <a:headEnd type="none" w="med" len="med"/>
+                      <a:tailEnd type="none" w="med" len="med"/>
+                    </a:lnR>
+                    <a:lnT w="9525" cap="flat" cmpd="sng" algn="ctr">
+                      <a:solidFill>
+                        <a:srgbClr val="D5DAE1"/>
+                      </a:solidFill>
+                      <a:prstDash val="solid"/>
+                      <a:round/>
+                      <a:headEnd type="none" w="med" len="med"/>
+                      <a:tailEnd type="none" w="med" len="med"/>
+                    </a:lnT>
+                    <a:lnB w="9525" cap="flat" cmpd="sng" algn="ctr">
+                      <a:solidFill>
+                        <a:srgbClr val="D5DAE1"/>
+                      </a:solidFill>
+                      <a:prstDash val="solid"/>
+                      <a:round/>
+                      <a:headEnd type="none" w="med" len="med"/>
+                      <a:tailEnd type="none" w="med" len="med"/>
+                    </a:lnB>
+                    <a:solidFill>
+                      <a:schemeClr val="tx2"/>
+                    </a:solidFill>
+                  </a:tcPr>
+                </a:tc>
+              </a:tr>
+              <a:tr h="384048">
+                <a:tc>
+                  <a:txBody>
+                    <a:bodyPr/>
+                    <a:lstStyle/>
+                    <a:p>
+                      <a:pPr indent="0" marL="0">
+                        <a:buNone/>
+                      </a:pPr>
+                      <a:r>
+                        <a:rPr lang="en-US" sz="1300" dirty="0">
+                          <a:solidFill>
+                            <a:schemeClr val="tx1"/>
+                          </a:solidFill>
+                        </a:rPr>
+                        <a:t>+ mMiniLM reranker (0.5 GB)</a:t>
+                      </a:r>
+                      <a:endParaRPr lang="en-US" sz="1300" dirty="0"/>
+                    </a:p>
+                  </a:txBody>
+                  <a:tcPr marL="54864" marR="54864" marT="54864" marB="54864" anchor="ctr">
+                    <a:lnL w="9525" cap="flat" cmpd="sng" algn="ctr">
+                      <a:solidFill>
+                        <a:srgbClr val="D5DAE1"/>
+                      </a:solidFill>
+                      <a:prstDash val="solid"/>
+                      <a:round/>
+                      <a:headEnd type="none" w="med" len="med"/>
+                      <a:tailEnd type="none" w="med" len="med"/>
+                    </a:lnL>
+                    <a:lnR w="9525" cap="flat" cmpd="sng" algn="ctr">
+                      <a:solidFill>
+                        <a:srgbClr val="D5DAE1"/>
+                      </a:solidFill>
+                      <a:prstDash val="solid"/>
+                      <a:round/>
+                      <a:headEnd type="none" w="med" len="med"/>
+                      <a:tailEnd type="none" w="med" len="med"/>
+                    </a:lnR>
+                    <a:lnT w="9525" cap="flat" cmpd="sng" algn="ctr">
+                      <a:solidFill>
+                        <a:srgbClr val="D5DAE1"/>
+                      </a:solidFill>
+                      <a:prstDash val="solid"/>
+                      <a:round/>
+                      <a:headEnd type="none" w="med" len="med"/>
+                      <a:tailEnd type="none" w="med" len="med"/>
+                    </a:lnT>
+                    <a:lnB w="9525" cap="flat" cmpd="sng" algn="ctr">
+                      <a:solidFill>
+                        <a:srgbClr val="D5DAE1"/>
+                      </a:solidFill>
+                      <a:prstDash val="solid"/>
+                      <a:round/>
+                      <a:headEnd type="none" w="med" len="med"/>
+                      <a:tailEnd type="none" w="med" len="med"/>
+                    </a:lnB>
+                    <a:solidFill>
+                      <a:schemeClr val="bg1"/>
+                    </a:solidFill>
+                  </a:tcPr>
+                </a:tc>
+                <a:tc>
+                  <a:txBody>
+                    <a:bodyPr/>
+                    <a:lstStyle/>
+                    <a:p>
+                      <a:pPr indent="0" marL="0">
+                        <a:buNone/>
+                      </a:pPr>
+                      <a:r>
+                        <a:rPr lang="en-US" sz="1300" dirty="0">
+                          <a:solidFill>
+                            <a:schemeClr val="tx1"/>
+                          </a:solidFill>
+                        </a:rPr>
+                        <a:t>+2.6 s</a:t>
+                      </a:r>
+                      <a:endParaRPr lang="en-US" sz="1300" dirty="0"/>
+                    </a:p>
+                  </a:txBody>
+                  <a:tcPr marL="54864" marR="54864" marT="54864" marB="54864" anchor="ctr">
+                    <a:lnL w="9525" cap="flat" cmpd="sng" algn="ctr">
+                      <a:solidFill>
+                        <a:srgbClr val="D5DAE1"/>
+                      </a:solidFill>
+                      <a:prstDash val="solid"/>
+                      <a:round/>
+                      <a:headEnd type="none" w="med" len="med"/>
+                      <a:tailEnd type="none" w="med" len="med"/>
+                    </a:lnL>
+                    <a:lnR w="9525" cap="flat" cmpd="sng" algn="ctr">
+                      <a:solidFill>
+                        <a:srgbClr val="D5DAE1"/>
+                      </a:solidFill>
+                      <a:prstDash val="solid"/>
+                      <a:round/>
+                      <a:headEnd type="none" w="med" len="med"/>
+                      <a:tailEnd type="none" w="med" len="med"/>
+                    </a:lnR>
+                    <a:lnT w="9525" cap="flat" cmpd="sng" algn="ctr">
+                      <a:solidFill>
+                        <a:srgbClr val="D5DAE1"/>
+                      </a:solidFill>
+                      <a:prstDash val="solid"/>
+                      <a:round/>
+                      <a:headEnd type="none" w="med" len="med"/>
+                      <a:tailEnd type="none" w="med" len="med"/>
+                    </a:lnT>
+                    <a:lnB w="9525" cap="flat" cmpd="sng" algn="ctr">
+                      <a:solidFill>
+                        <a:srgbClr val="D5DAE1"/>
+                      </a:solidFill>
+                      <a:prstDash val="solid"/>
+                      <a:round/>
+                      <a:headEnd type="none" w="med" len="med"/>
+                      <a:tailEnd type="none" w="med" len="med"/>
+                    </a:lnB>
+                    <a:solidFill>
+                      <a:schemeClr val="bg1"/>
+                    </a:solidFill>
+                  </a:tcPr>
+                </a:tc>
+              </a:tr>
+              <a:tr h="384048">
+                <a:tc>
+                  <a:txBody>
+                    <a:bodyPr/>
+                    <a:lstStyle/>
+                    <a:p>
+                      <a:pPr indent="0" marL="0">
+                        <a:buNone/>
+                      </a:pPr>
+                      <a:r>
+                        <a:rPr lang="en-US" sz="1300" dirty="0">
+                          <a:solidFill>
+                            <a:schemeClr val="tx1"/>
+                          </a:solidFill>
+                        </a:rPr>
+                        <a:t>+ bge-reranker (2.3 GB)</a:t>
+                      </a:r>
+                      <a:endParaRPr lang="en-US" sz="1300" dirty="0"/>
+                    </a:p>
+                  </a:txBody>
+                  <a:tcPr marL="54864" marR="54864" marT="54864" marB="54864" anchor="ctr">
+                    <a:lnL w="9525" cap="flat" cmpd="sng" algn="ctr">
+                      <a:solidFill>
+                        <a:srgbClr val="D5DAE1"/>
+                      </a:solidFill>
+                      <a:prstDash val="solid"/>
+                      <a:round/>
+                      <a:headEnd type="none" w="med" len="med"/>
+                      <a:tailEnd type="none" w="med" len="med"/>
+                    </a:lnL>
+                    <a:lnR w="9525" cap="flat" cmpd="sng" algn="ctr">
+                      <a:solidFill>
+                        <a:srgbClr val="D5DAE1"/>
+                      </a:solidFill>
+                      <a:prstDash val="solid"/>
+                      <a:round/>
+                      <a:headEnd type="none" w="med" len="med"/>
+                      <a:tailEnd type="none" w="med" len="med"/>
+                    </a:lnR>
+                    <a:lnT w="9525" cap="flat" cmpd="sng" algn="ctr">
+                      <a:solidFill>
+                        <a:srgbClr val="D5DAE1"/>
+                      </a:solidFill>
+                      <a:prstDash val="solid"/>
+                      <a:round/>
+                      <a:headEnd type="none" w="med" len="med"/>
+                      <a:tailEnd type="none" w="med" len="med"/>
+                    </a:lnT>
+                    <a:lnB w="9525" cap="flat" cmpd="sng" algn="ctr">
+                      <a:solidFill>
+                        <a:srgbClr val="D5DAE1"/>
+                      </a:solidFill>
+                      <a:prstDash val="solid"/>
+                      <a:round/>
+                      <a:headEnd type="none" w="med" len="med"/>
+                      <a:tailEnd type="none" w="med" len="med"/>
+                    </a:lnB>
+                    <a:solidFill>
+                      <a:schemeClr val="bg1"/>
+                    </a:solidFill>
+                  </a:tcPr>
+                </a:tc>
+                <a:tc>
+                  <a:txBody>
+                    <a:bodyPr/>
+                    <a:lstStyle/>
+                    <a:p>
+                      <a:pPr indent="0" marL="0">
+                        <a:buNone/>
+                      </a:pPr>
+                      <a:r>
+                        <a:rPr lang="en-US" sz="1300" dirty="0">
+                          <a:solidFill>
+                            <a:schemeClr val="tx1"/>
+                          </a:solidFill>
+                        </a:rPr>
+                        <a:t>+19.4 s</a:t>
+                      </a:r>
+                      <a:endParaRPr lang="en-US" sz="1300" dirty="0"/>
+                    </a:p>
+                  </a:txBody>
+                  <a:tcPr marL="54864" marR="54864" marT="54864" marB="54864" anchor="ctr">
+                    <a:lnL w="9525" cap="flat" cmpd="sng" algn="ctr">
+                      <a:solidFill>
+                        <a:srgbClr val="D5DAE1"/>
+                      </a:solidFill>
+                      <a:prstDash val="solid"/>
+                      <a:round/>
+                      <a:headEnd type="none" w="med" len="med"/>
+                      <a:tailEnd type="none" w="med" len="med"/>
+                    </a:lnL>
+                    <a:lnR w="9525" cap="flat" cmpd="sng" algn="ctr">
+                      <a:solidFill>
+                        <a:srgbClr val="D5DAE1"/>
+                      </a:solidFill>
+                      <a:prstDash val="solid"/>
+                      <a:round/>
+                      <a:headEnd type="none" w="med" len="med"/>
+                      <a:tailEnd type="none" w="med" len="med"/>
+                    </a:lnR>
+                    <a:lnT w="9525" cap="flat" cmpd="sng" algn="ctr">
+                      <a:solidFill>
+                        <a:srgbClr val="D5DAE1"/>
+                      </a:solidFill>
+                      <a:prstDash val="solid"/>
+                      <a:round/>
+                      <a:headEnd type="none" w="med" len="med"/>
+                      <a:tailEnd type="none" w="med" len="med"/>
+                    </a:lnT>
+                    <a:lnB w="9525" cap="flat" cmpd="sng" algn="ctr">
+                      <a:solidFill>
+                        <a:srgbClr val="D5DAE1"/>
+                      </a:solidFill>
+                      <a:prstDash val="solid"/>
+                      <a:round/>
+                      <a:headEnd type="none" w="med" len="med"/>
+                      <a:tailEnd type="none" w="med" len="med"/>
+                    </a:lnB>
+                    <a:solidFill>
+                      <a:schemeClr val="bg1"/>
+                    </a:solidFill>
+                  </a:tcPr>
+                </a:tc>
+              </a:tr>
+              <a:tr h="384048">
+                <a:tc>
+                  <a:txBody>
+                    <a:bodyPr/>
+                    <a:lstStyle/>
+                    <a:p>
+                      <a:pPr indent="0" marL="0">
+                        <a:buNone/>
+                      </a:pPr>
+                      <a:r>
+                        <a:rPr lang="en-US" sz="1300" b="1" dirty="0">
+                          <a:solidFill>
+                            <a:schemeClr val="tx1"/>
+                          </a:solidFill>
+                        </a:rPr>
+                        <a:t>Meaning ×3 (a setting)</a:t>
+                      </a:r>
+                      <a:endParaRPr lang="en-US" sz="1300" dirty="0"/>
+                    </a:p>
+                  </a:txBody>
+                  <a:tcPr marL="54864" marR="54864" marT="54864" marB="54864" anchor="ctr">
+                    <a:lnL w="9525" cap="flat" cmpd="sng" algn="ctr">
+                      <a:solidFill>
+                        <a:srgbClr val="D5DAE1"/>
+                      </a:solidFill>
+                      <a:prstDash val="solid"/>
+                      <a:round/>
+                      <a:headEnd type="none" w="med" len="med"/>
+                      <a:tailEnd type="none" w="med" len="med"/>
+                    </a:lnL>
+                    <a:lnR w="9525" cap="flat" cmpd="sng" algn="ctr">
+                      <a:solidFill>
+                        <a:srgbClr val="D5DAE1"/>
+                      </a:solidFill>
+                      <a:prstDash val="solid"/>
+                      <a:round/>
+                      <a:headEnd type="none" w="med" len="med"/>
+                      <a:tailEnd type="none" w="med" len="med"/>
+                    </a:lnR>
+                    <a:lnT w="9525" cap="flat" cmpd="sng" algn="ctr">
+                      <a:solidFill>
+                        <a:srgbClr val="D5DAE1"/>
+                      </a:solidFill>
+                      <a:prstDash val="solid"/>
+                      <a:round/>
+                      <a:headEnd type="none" w="med" len="med"/>
+                      <a:tailEnd type="none" w="med" len="med"/>
+                    </a:lnT>
+                    <a:lnB w="9525" cap="flat" cmpd="sng" algn="ctr">
+                      <a:solidFill>
+                        <a:srgbClr val="D5DAE1"/>
+                      </a:solidFill>
+                      <a:prstDash val="solid"/>
+                      <a:round/>
+                      <a:headEnd type="none" w="med" len="med"/>
+                      <a:tailEnd type="none" w="med" len="med"/>
+                    </a:lnB>
+                    <a:solidFill>
+                      <a:schemeClr val="bg1"/>
+                    </a:solidFill>
+                  </a:tcPr>
+                </a:tc>
+                <a:tc>
+                  <a:txBody>
+                    <a:bodyPr/>
+                    <a:lstStyle/>
+                    <a:p>
+                      <a:pPr indent="0" marL="0">
+                        <a:buNone/>
+                      </a:pPr>
+                      <a:r>
+                        <a:rPr lang="en-US" sz="1300" b="1" dirty="0">
+                          <a:solidFill>
+                            <a:schemeClr val="tx1"/>
+                          </a:solidFill>
+                        </a:rPr>
+                        <a:t>0 s</a:t>
+                      </a:r>
+                      <a:endParaRPr lang="en-US" sz="1300" dirty="0"/>
+                    </a:p>
+                  </a:txBody>
+                  <a:tcPr marL="54864" marR="54864" marT="54864" marB="54864" anchor="ctr">
+                    <a:lnL w="9525" cap="flat" cmpd="sng" algn="ctr">
+                      <a:solidFill>
+                        <a:srgbClr val="D5DAE1"/>
+                      </a:solidFill>
+                      <a:prstDash val="solid"/>
+                      <a:round/>
+                      <a:headEnd type="none" w="med" len="med"/>
+                      <a:tailEnd type="none" w="med" len="med"/>
+                    </a:lnL>
+                    <a:lnR w="9525" cap="flat" cmpd="sng" algn="ctr">
+                      <a:solidFill>
+                        <a:srgbClr val="D5DAE1"/>
+                      </a:solidFill>
+                      <a:prstDash val="solid"/>
+                      <a:round/>
+                      <a:headEnd type="none" w="med" len="med"/>
+                      <a:tailEnd type="none" w="med" len="med"/>
+                    </a:lnR>
+                    <a:lnT w="9525" cap="flat" cmpd="sng" algn="ctr">
+                      <a:solidFill>
+                        <a:srgbClr val="D5DAE1"/>
+                      </a:solidFill>
+                      <a:prstDash val="solid"/>
+                      <a:round/>
+                      <a:headEnd type="none" w="med" len="med"/>
+                      <a:tailEnd type="none" w="med" len="med"/>
+                    </a:lnT>
+                    <a:lnB w="9525" cap="flat" cmpd="sng" algn="ctr">
+                      <a:solidFill>
+                        <a:srgbClr val="D5DAE1"/>
+                      </a:solidFill>
+                      <a:prstDash val="solid"/>
+                      <a:round/>
+                      <a:headEnd type="none" w="med" len="med"/>
+                      <a:tailEnd type="none" w="med" len="med"/>
+                    </a:lnB>
+                    <a:solidFill>
+                      <a:schemeClr val="bg1"/>
+                    </a:solidFill>
+                  </a:tcPr>
+                </a:tc>
+              </a:tr>
+            </a:tbl>
+          </a:graphicData>
+        </a:graphic>
+      </p:graphicFrame>
+      <p:sp>
+        <p:nvSpPr>
+          <p:cNvPr id="6" name="Rerank decision"/>
+          <p:cNvSpPr/>
+          <p:nvPr/>
+        </p:nvSpPr>
+        <p:spPr>
+          <a:xfrm>
+            <a:off x="7452360" y="3429000"/>
+            <a:ext cx="4206240" cy="2286000"/>
+          </a:xfrm>
+          <a:prstGeom prst="roundRect">
+            <a:avLst>
+              <a:gd name="adj" fmla="val 4800"/>
+            </a:avLst>
+          </a:prstGeom>
+          <a:solidFill>
+            <a:schemeClr val="bg2"/>
+          </a:solidFill>
+          <a:ln w="22225">
+            <a:solidFill>
+              <a:schemeClr val="accent1"/>
+            </a:solidFill>
+            <a:prstDash val="solid"/>
+          </a:ln>
+        </p:spPr>
+      </p:sp>
+      <p:sp>
+        <p:nvSpPr>
+          <p:cNvPr id="7" name="Rerank decision text"/>
+          <p:cNvSpPr txBox="1"/>
+          <p:nvPr/>
+        </p:nvSpPr>
+        <p:spPr>
+          <a:xfrm>
+            <a:off x="7635240" y="3474720"/>
+            <a:ext cx="3886200" cy="2194560"/>
+          </a:xfrm>
+          <a:prstGeom prst="rect">
+            <a:avLst/>
+          </a:prstGeom>
+          <a:noFill/>
+          <a:ln/>
+        </p:spPr>
+        <p:txBody>
+          <a:bodyPr wrap="square" lIns="0" tIns="0" rIns="0" bIns="0" rtlCol="0" anchor="ctr"/>
+          <a:lstStyle/>
+          <a:p>
+            <a:pPr indent="0" marL="0">
+              <a:buNone/>
+            </a:pPr>
+            <a:r>
+              <a:rPr lang="en-US" sz="1300" b="1" dirty="0">
+                <a:solidFill>
+                  <a:schemeClr val="accent1"/>
+                </a:solidFill>
+              </a:rPr>
+              <a:t>Decision: </a:t>
+            </a:r>
+            <a:pPr indent="0" marL="0">
+              <a:buNone/>
+            </a:pPr>
+            <a:r>
+              <a:rPr lang="en-US" sz="1300" dirty="0">
+                <a:solidFill>
+                  <a:schemeClr val="tx1"/>
+                </a:solidFill>
+              </a:rPr>
+              <a:t>default = hybrid with meaning ×3. bge-reranker stays as an on/off option: built and measured, off on a laptop CPU. Picked on dev with a rule fixed in advance; held-out only checked after.</a:t>
+            </a:r>
+            <a:endParaRPr lang="en-US" sz="1300" dirty="0"/>
+          </a:p>
+        </p:txBody>
+      </p:sp>
+      <p:sp>
+        <p:nvSpPr>
+          <p:cNvPr id="8" name="Rerank tradeoff"/>
+          <p:cNvSpPr txBox="1"/>
+          <p:nvPr/>
+        </p:nvSpPr>
+        <p:spPr>
+          <a:xfrm>
+            <a:off x="548640" y="5806440"/>
+            <a:ext cx="11109960" cy="365760"/>
+          </a:xfrm>
+          <a:prstGeom prst="rect">
+            <a:avLst/>
+          </a:prstGeom>
+          <a:noFill/>
+          <a:ln/>
+        </p:spPr>
+        <p:txBody>
+          <a:bodyPr wrap="square" lIns="0" tIns="0" rIns="0" bIns="0" rtlCol="0" anchor="ctr"/>
+          <a:lstStyle/>
+          <a:p>
+            <a:pPr indent="0" marL="0">
+              <a:buNone/>
+            </a:pPr>
+            <a:r>
+              <a:rPr lang="en-US" sz="1300" i="1" dirty="0">
+                <a:solidFill>
+                  <a:schemeClr val="tx1"/>
+                </a:solidFill>
+              </a:rPr>
+              <a:t>This is the brief's “cost/latency trade-off”: +6 points on dev, +0 on held-out, for +19 s per question.</a:t>
+            </a:r>
+            <a:endParaRPr lang="en-US" sz="1300" dirty="0"/>
+          </a:p>
+        </p:txBody>
+      </p:sp>
+      <p:sp>
+        <p:nvSpPr>
+          <p:cNvPr id="9" name="Rerank footnote"/>
+          <p:cNvSpPr txBox="1"/>
+          <p:nvPr/>
+        </p:nvSpPr>
+        <p:spPr>
+          <a:xfrm>
+            <a:off x="548640" y="6400800"/>
+            <a:ext cx="11064240" cy="274320"/>
+          </a:xfrm>
+          <a:prstGeom prst="rect">
+            <a:avLst/>
+          </a:prstGeom>
+          <a:noFill/>
+          <a:ln/>
+        </p:spPr>
+        <p:txBody>
+          <a:bodyPr wrap="square" lIns="0" tIns="0" rIns="0" bIns="0" rtlCol="0" anchor="ctr"/>
+          <a:lstStyle/>
+          <a:p>
+            <a:pPr indent="0" marL="0">
+              <a:buNone/>
+            </a:pPr>
+            <a:r>
+              <a:rPr lang="en-US" sz="1000" dirty="0">
+                <a:solidFill>
+                  <a:schemeClr val="accent6"/>
+                </a:solidFill>
+              </a:rPr>
+              <a:t>Source: eval/retrieval_rerank.json, eval/retrieval_fusion.json. Rerankers re-sort the top 10 pieces. No model was trained: all are ready-made and only measured.</a:t>
+            </a:r>
+            <a:endParaRPr lang="en-US" sz="1000" dirty="0"/>
+          </a:p>
+        </p:txBody>
+      </p:sp>
+    </p:spTree>
+  </p:cSld>
+  <p:clrMapOvr>
+    <a:masterClrMapping/>
+  </p:clrMapOvr>
+</p:sld>
+</file>
+
+<file path=ppt/slides/slide13.xml><?xml version="1.0" encoding="utf-8"?>
+<p:sld xmlns:a="http://schemas.openxmlformats.org/drawingml/2006/main" xmlns:r="http://schemas.openxmlformats.org/officeDocument/2006/relationships" xmlns:p="http://schemas.openxmlformats.org/presentationml/2006/main">
+  <p:cSld name="Slide 13">
+    <p:spTree>
+      <p:nvGrpSpPr>
+        <p:cNvPr id="1" name=""/>
+        <p:cNvGrpSpPr/>
+        <p:nvPr/>
+      </p:nvGrpSpPr>
+      <p:grpSpPr>
+        <a:xfrm>
+          <a:off x="0" y="0"/>
+          <a:ext cx="0" cy="0"/>
+          <a:chOff x="0" y="0"/>
+          <a:chExt cx="0" cy="0"/>
+        </a:xfrm>
+      </p:grpSpPr>
+      <p:sp>
+        <p:nvSpPr>
+          <p:cNvPr id="2" name="Text 0"/>
+          <p:cNvSpPr/>
+          <p:nvPr>
+            <p:ph idx="100" type="title" hasCustomPrompt="1"/>
+          </p:nvPr>
+        </p:nvSpPr>
+        <p:spPr>
+          <a:xfrm>
+            <a:off x="548640" y="320040"/>
+            <a:ext cx="9144000" cy="685800"/>
+          </a:xfrm>
+          <a:prstGeom prst="rect">
+            <a:avLst/>
+          </a:prstGeom>
+          <a:noFill/>
+          <a:ln/>
+        </p:spPr>
+        <p:txBody>
+          <a:bodyPr wrap="square" lIns="0" tIns="0" rIns="0" bIns="0" rtlCol="0" anchor="ctr"/>
+          <a:lstStyle/>
+          <a:p>
+            <a:pPr algn="l" indent="0" marL="0">
+              <a:buNone/>
+            </a:pPr>
+            <a:r>
+              <a:rPr lang="en-US" sz="3000" b="1" dirty="0">
+                <a:solidFill>
+                  <a:schemeClr val="tx2"/>
+                </a:solidFill>
+              </a:rPr>
               <a:t>Decision log: what we chose, and the evidence</a:t>
             </a:r>
             <a:endParaRPr lang="en-US" sz="3000" dirty="0"/>
@@ -8248,7 +9508,7 @@
       </p:sp>
       <p:graphicFrame>
         <p:nvGraphicFramePr>
-          <p:cNvPr id="13" name="Decision table"/>
+          <p:cNvPr id="14" name="Decision table"/>
           <p:cNvGraphicFramePr>
             <a:graphicFrameLocks noGrp="1"/>
           </p:cNvGraphicFramePr>
@@ -9826,7 +11086,7 @@
                             <a:schemeClr val="tx1"/>
                           </a:solidFill>
                         </a:rPr>
-                        <a:t>Reciprocal Rank Fusion (k = 60)</a:t>
+                        <a:t>Rank fusion, meaning counts ×3</a:t>
                       </a:r>
                       <a:endParaRPr lang="en-US" sz="1300" dirty="0"/>
                     </a:p>
@@ -9887,7 +11147,7 @@
                             <a:schemeClr val="tx1"/>
                           </a:solidFill>
                         </a:rPr>
-                        <a:t>Uses ranks only: no score scaling to tune</a:t>
+                        <a:t>Rank-1 held-out 75% → 88%, at zero cost; picked on dev</a:t>
                       </a:r>
                       <a:endParaRPr lang="en-US" sz="1300" dirty="0"/>
                     </a:p>
@@ -10318,7 +11578,7 @@
                             <a:schemeClr val="tx1"/>
                           </a:solidFill>
                         </a:rPr>
-                        <a:t>mMiniLM (0.5 GB) tested first</a:t>
+                        <a:t>bge-reranker as an option, off by default</a:t>
                       </a:r>
                       <a:endParaRPr lang="en-US" sz="1300" dirty="0"/>
                     </a:p>
@@ -10379,7 +11639,7 @@
                             <a:schemeClr val="tx1"/>
                           </a:solidFill>
                         </a:rPr>
-                        <a:t>Small, multilingual; benchmark next</a:t>
+                        <a:t>+0 held-out for +19 s per question on CPU; mMiniLM made it worse</a:t>
                       </a:r>
                       <a:endParaRPr lang="en-US" sz="1300" dirty="0"/>
                     </a:p>
@@ -10437,10 +11697,10 @@
                       <a:r>
                         <a:rPr lang="en-US" sz="1300" b="1" dirty="0">
                           <a:solidFill>
-                            <a:schemeClr val="accent2"/>
+                            <a:schemeClr val="accent1"/>
                           </a:solidFill>
                         </a:rPr>
-                        <a:t>Next</a:t>
+                        <a:t>Done</a:t>
                       </a:r>
                       <a:endParaRPr lang="en-US" sz="1300" dirty="0"/>
                     </a:p>
@@ -10523,1500 +11783,6 @@
                 </a:solidFill>
               </a:rPr>
               <a:t>Earlier decisions (use case, 504-aid subset, git rules) are on slides 2–3.</a:t>
-            </a:r>
-            <a:endParaRPr lang="en-US" sz="1000" dirty="0"/>
-          </a:p>
-        </p:txBody>
-      </p:sp>
-    </p:spTree>
-  </p:cSld>
-  <p:clrMapOvr>
-    <a:masterClrMapping/>
-  </p:clrMapOvr>
-</p:sld>
-</file>
-
-<file path=ppt/slides/slide13.xml><?xml version="1.0" encoding="utf-8"?>
-<p:sld xmlns:a="http://schemas.openxmlformats.org/drawingml/2006/main" xmlns:r="http://schemas.openxmlformats.org/officeDocument/2006/relationships" xmlns:p="http://schemas.openxmlformats.org/presentationml/2006/main">
-  <p:cSld name="Slide 13">
-    <p:spTree>
-      <p:nvGrpSpPr>
-        <p:cNvPr id="1" name=""/>
-        <p:cNvGrpSpPr/>
-        <p:nvPr/>
-      </p:nvGrpSpPr>
-      <p:grpSpPr>
-        <a:xfrm>
-          <a:off x="0" y="0"/>
-          <a:ext cx="0" cy="0"/>
-          <a:chOff x="0" y="0"/>
-          <a:chExt cx="0" cy="0"/>
-        </a:xfrm>
-      </p:grpSpPr>
-      <p:sp>
-        <p:nvSpPr>
-          <p:cNvPr id="2" name="Text 0"/>
-          <p:cNvSpPr/>
-          <p:nvPr>
-            <p:ph idx="100" type="title" hasCustomPrompt="1"/>
-          </p:nvPr>
-        </p:nvSpPr>
-        <p:spPr>
-          <a:xfrm>
-            <a:off x="548640" y="320040"/>
-            <a:ext cx="9144000" cy="685800"/>
-          </a:xfrm>
-          <a:prstGeom prst="rect">
-            <a:avLst/>
-          </a:prstGeom>
-          <a:noFill/>
-          <a:ln/>
-        </p:spPr>
-        <p:txBody>
-          <a:bodyPr wrap="square" lIns="0" tIns="0" rIns="0" bIns="0" rtlCol="0" anchor="ctr"/>
-          <a:lstStyle/>
-          <a:p>
-            <a:pPr algn="l" indent="0" marL="0">
-              <a:buNone/>
-            </a:pPr>
-            <a:r>
-              <a:rPr lang="en-US" sz="3000" b="1" dirty="0">
-                <a:solidFill>
-                  <a:schemeClr val="tx2"/>
-                </a:solidFill>
-              </a:rPr>
-              <a:t>How we work: 8 pull requests, 35 automated checks</a:t>
-            </a:r>
-            <a:endParaRPr lang="en-US" sz="3000" dirty="0"/>
-          </a:p>
-        </p:txBody>
-      </p:sp>
-      <p:sp>
-        <p:nvSpPr>
-          <p:cNvPr id="3" name="Work subtitle"/>
-          <p:cNvSpPr txBox="1"/>
-          <p:nvPr/>
-        </p:nvSpPr>
-        <p:spPr>
-          <a:xfrm>
-            <a:off x="548640" y="1005840"/>
-            <a:ext cx="11064240" cy="320040"/>
-          </a:xfrm>
-          <a:prstGeom prst="rect">
-            <a:avLst/>
-          </a:prstGeom>
-          <a:noFill/>
-          <a:ln/>
-        </p:spPr>
-        <p:txBody>
-          <a:bodyPr wrap="square" lIns="0" tIns="0" rIns="0" bIns="0" rtlCol="0" anchor="ctr"/>
-          <a:lstStyle/>
-          <a:p>
-            <a:pPr indent="0" marL="0">
-              <a:buNone/>
-            </a:pPr>
-            <a:r>
-              <a:rPr lang="en-US" sz="1400" dirty="0">
-                <a:solidFill>
-                  <a:schemeClr val="accent6"/>
-                </a:solidFill>
-              </a:rPr>
-              <a:t>Every change goes through a pull request (PR): a proposal that a teammate reviews before it joins main</a:t>
-            </a:r>
-            <a:endParaRPr lang="en-US" sz="1400" dirty="0"/>
-          </a:p>
-        </p:txBody>
-      </p:sp>
-      <p:sp>
-        <p:nvSpPr>
-          <p:cNvPr id="4" name="PR legend dot Merged"/>
-          <p:cNvSpPr/>
-          <p:nvPr/>
-        </p:nvSpPr>
-        <p:spPr>
-          <a:xfrm>
-            <a:off x="10012680" y="429768"/>
-            <a:ext cx="137160" cy="137160"/>
-          </a:xfrm>
-          <a:prstGeom prst="ellipse">
-            <a:avLst/>
-          </a:prstGeom>
-          <a:solidFill>
-            <a:schemeClr val="accent1"/>
-          </a:solidFill>
-          <a:ln w="12700">
-            <a:solidFill>
-              <a:schemeClr val="accent1"/>
-            </a:solidFill>
-            <a:prstDash val="solid"/>
-          </a:ln>
-        </p:spPr>
-      </p:sp>
-      <p:sp>
-        <p:nvSpPr>
-          <p:cNvPr id="5" name="PR legend Merged"/>
-          <p:cNvSpPr txBox="1"/>
-          <p:nvPr/>
-        </p:nvSpPr>
-        <p:spPr>
-          <a:xfrm>
-            <a:off x="10222992" y="384048"/>
-            <a:ext cx="1737360" cy="228600"/>
-          </a:xfrm>
-          <a:prstGeom prst="rect">
-            <a:avLst/>
-          </a:prstGeom>
-          <a:noFill/>
-          <a:ln/>
-        </p:spPr>
-        <p:txBody>
-          <a:bodyPr wrap="square" lIns="0" tIns="0" rIns="0" bIns="0" rtlCol="0" anchor="ctr"/>
-          <a:lstStyle/>
-          <a:p>
-            <a:pPr indent="0" marL="0">
-              <a:buNone/>
-            </a:pPr>
-            <a:r>
-              <a:rPr lang="en-US" sz="1200" dirty="0">
-                <a:solidFill>
-                  <a:schemeClr val="tx1"/>
-                </a:solidFill>
-              </a:rPr>
-              <a:t>Merged</a:t>
-            </a:r>
-            <a:endParaRPr lang="en-US" sz="1200" dirty="0"/>
-          </a:p>
-        </p:txBody>
-      </p:sp>
-      <p:sp>
-        <p:nvSpPr>
-          <p:cNvPr id="6" name="PR legend dot Open"/>
-          <p:cNvSpPr/>
-          <p:nvPr/>
-        </p:nvSpPr>
-        <p:spPr>
-          <a:xfrm>
-            <a:off x="10012680" y="676656"/>
-            <a:ext cx="137160" cy="137160"/>
-          </a:xfrm>
-          <a:prstGeom prst="ellipse">
-            <a:avLst/>
-          </a:prstGeom>
-          <a:solidFill>
-            <a:schemeClr val="accent2"/>
-          </a:solidFill>
-          <a:ln w="12700">
-            <a:solidFill>
-              <a:schemeClr val="accent2"/>
-            </a:solidFill>
-            <a:prstDash val="solid"/>
-          </a:ln>
-        </p:spPr>
-      </p:sp>
-      <p:sp>
-        <p:nvSpPr>
-          <p:cNvPr id="7" name="PR legend Open"/>
-          <p:cNvSpPr txBox="1"/>
-          <p:nvPr/>
-        </p:nvSpPr>
-        <p:spPr>
-          <a:xfrm>
-            <a:off x="10222992" y="630936"/>
-            <a:ext cx="1737360" cy="228600"/>
-          </a:xfrm>
-          <a:prstGeom prst="rect">
-            <a:avLst/>
-          </a:prstGeom>
-          <a:noFill/>
-          <a:ln/>
-        </p:spPr>
-        <p:txBody>
-          <a:bodyPr wrap="square" lIns="0" tIns="0" rIns="0" bIns="0" rtlCol="0" anchor="ctr"/>
-          <a:lstStyle/>
-          <a:p>
-            <a:pPr indent="0" marL="0">
-              <a:buNone/>
-            </a:pPr>
-            <a:r>
-              <a:rPr lang="en-US" sz="1200" dirty="0">
-                <a:solidFill>
-                  <a:schemeClr val="tx1"/>
-                </a:solidFill>
-              </a:rPr>
-              <a:t>Open</a:t>
-            </a:r>
-            <a:endParaRPr lang="en-US" sz="1200" dirty="0"/>
-          </a:p>
-        </p:txBody>
-      </p:sp>
-      <p:sp>
-        <p:nvSpPr>
-          <p:cNvPr id="8" name="PR line"/>
-          <p:cNvSpPr/>
-          <p:nvPr/>
-        </p:nvSpPr>
-        <p:spPr>
-          <a:xfrm>
-            <a:off x="914400" y="2240280"/>
-            <a:ext cx="10332720" cy="0"/>
-          </a:xfrm>
-          <a:prstGeom prst="line">
-            <a:avLst/>
-          </a:prstGeom>
-          <a:noFill/>
-          <a:ln w="25400">
-            <a:solidFill>
-              <a:schemeClr val="accent4"/>
-            </a:solidFill>
-            <a:prstDash val="solid"/>
-          </a:ln>
-        </p:spPr>
-      </p:sp>
-      <p:sp>
-        <p:nvSpPr>
-          <p:cNvPr id="9" name="PR node #1"/>
-          <p:cNvSpPr/>
-          <p:nvPr/>
-        </p:nvSpPr>
-        <p:spPr>
-          <a:xfrm>
-            <a:off x="640080" y="1965960"/>
-            <a:ext cx="548640" cy="548640"/>
-          </a:xfrm>
-          <a:prstGeom prst="ellipse">
-            <a:avLst/>
-          </a:prstGeom>
-          <a:solidFill>
-            <a:schemeClr val="accent1"/>
-          </a:solidFill>
-          <a:ln w="12700">
-            <a:solidFill>
-              <a:schemeClr val="accent1"/>
-            </a:solidFill>
-            <a:prstDash val="solid"/>
-          </a:ln>
-        </p:spPr>
-      </p:sp>
-      <p:sp>
-        <p:nvSpPr>
-          <p:cNvPr id="10" name="PR num #1"/>
-          <p:cNvSpPr txBox="1"/>
-          <p:nvPr/>
-        </p:nvSpPr>
-        <p:spPr>
-          <a:xfrm>
-            <a:off x="640080" y="1965960"/>
-            <a:ext cx="548640" cy="548640"/>
-          </a:xfrm>
-          <a:prstGeom prst="rect">
-            <a:avLst/>
-          </a:prstGeom>
-          <a:noFill/>
-          <a:ln/>
-        </p:spPr>
-        <p:txBody>
-          <a:bodyPr wrap="square" lIns="0" tIns="0" rIns="0" bIns="0" rtlCol="0" anchor="ctr"/>
-          <a:lstStyle/>
-          <a:p>
-            <a:pPr algn="ctr" indent="0" marL="0">
-              <a:buNone/>
-            </a:pPr>
-            <a:r>
-              <a:rPr lang="en-US" sz="1300" b="1" dirty="0">
-                <a:solidFill>
-                  <a:schemeClr val="bg1"/>
-                </a:solidFill>
-              </a:rPr>
-              <a:t>#1</a:t>
-            </a:r>
-            <a:endParaRPr lang="en-US" sz="1300" dirty="0"/>
-          </a:p>
-        </p:txBody>
-      </p:sp>
-      <p:sp>
-        <p:nvSpPr>
-          <p:cNvPr id="11" name="PR name #1"/>
-          <p:cNvSpPr txBox="1"/>
-          <p:nvPr/>
-        </p:nvSpPr>
-        <p:spPr>
-          <a:xfrm>
-            <a:off x="274320" y="2606040"/>
-            <a:ext cx="1280160" cy="548640"/>
-          </a:xfrm>
-          <a:prstGeom prst="rect">
-            <a:avLst/>
-          </a:prstGeom>
-          <a:noFill/>
-          <a:ln/>
-        </p:spPr>
-        <p:txBody>
-          <a:bodyPr wrap="square" lIns="0" tIns="0" rIns="0" bIns="0" rtlCol="0" anchor="t"/>
-          <a:lstStyle/>
-          <a:p>
-            <a:pPr algn="ctr" indent="0" marL="0">
-              <a:buNone/>
-            </a:pPr>
-            <a:r>
-              <a:rPr lang="en-US" sz="1200" b="1" dirty="0">
-                <a:solidFill>
-                  <a:schemeClr val="tx1"/>
-                </a:solidFill>
-              </a:rPr>
-              <a:t>Data source &amp; licence</a:t>
-            </a:r>
-            <a:endParaRPr lang="en-US" sz="1200" dirty="0"/>
-          </a:p>
-        </p:txBody>
-      </p:sp>
-      <p:sp>
-        <p:nvSpPr>
-          <p:cNvPr id="12" name="PR node #2"/>
-          <p:cNvSpPr/>
-          <p:nvPr/>
-        </p:nvSpPr>
-        <p:spPr>
-          <a:xfrm>
-            <a:off x="2116183" y="1965960"/>
-            <a:ext cx="548640" cy="548640"/>
-          </a:xfrm>
-          <a:prstGeom prst="ellipse">
-            <a:avLst/>
-          </a:prstGeom>
-          <a:solidFill>
-            <a:schemeClr val="accent1"/>
-          </a:solidFill>
-          <a:ln w="12700">
-            <a:solidFill>
-              <a:schemeClr val="accent1"/>
-            </a:solidFill>
-            <a:prstDash val="solid"/>
-          </a:ln>
-        </p:spPr>
-      </p:sp>
-      <p:sp>
-        <p:nvSpPr>
-          <p:cNvPr id="13" name="PR num #2"/>
-          <p:cNvSpPr txBox="1"/>
-          <p:nvPr/>
-        </p:nvSpPr>
-        <p:spPr>
-          <a:xfrm>
-            <a:off x="2116183" y="1965960"/>
-            <a:ext cx="548640" cy="548640"/>
-          </a:xfrm>
-          <a:prstGeom prst="rect">
-            <a:avLst/>
-          </a:prstGeom>
-          <a:noFill/>
-          <a:ln/>
-        </p:spPr>
-        <p:txBody>
-          <a:bodyPr wrap="square" lIns="0" tIns="0" rIns="0" bIns="0" rtlCol="0" anchor="ctr"/>
-          <a:lstStyle/>
-          <a:p>
-            <a:pPr algn="ctr" indent="0" marL="0">
-              <a:buNone/>
-            </a:pPr>
-            <a:r>
-              <a:rPr lang="en-US" sz="1300" b="1" dirty="0">
-                <a:solidFill>
-                  <a:schemeClr val="bg1"/>
-                </a:solidFill>
-              </a:rPr>
-              <a:t>#2</a:t>
-            </a:r>
-            <a:endParaRPr lang="en-US" sz="1300" dirty="0"/>
-          </a:p>
-        </p:txBody>
-      </p:sp>
-      <p:sp>
-        <p:nvSpPr>
-          <p:cNvPr id="14" name="PR name #2"/>
-          <p:cNvSpPr txBox="1"/>
-          <p:nvPr/>
-        </p:nvSpPr>
-        <p:spPr>
-          <a:xfrm>
-            <a:off x="1750423" y="2606040"/>
-            <a:ext cx="1280160" cy="548640"/>
-          </a:xfrm>
-          <a:prstGeom prst="rect">
-            <a:avLst/>
-          </a:prstGeom>
-          <a:noFill/>
-          <a:ln/>
-        </p:spPr>
-        <p:txBody>
-          <a:bodyPr wrap="square" lIns="0" tIns="0" rIns="0" bIns="0" rtlCol="0" anchor="t"/>
-          <a:lstStyle/>
-          <a:p>
-            <a:pPr algn="ctr" indent="0" marL="0">
-              <a:buNone/>
-            </a:pPr>
-            <a:r>
-              <a:rPr lang="en-US" sz="1200" b="1" dirty="0">
-                <a:solidFill>
-                  <a:schemeClr val="tx1"/>
-                </a:solidFill>
-              </a:rPr>
-              <a:t>Dashboard &amp; slides</a:t>
-            </a:r>
-            <a:endParaRPr lang="en-US" sz="1200" dirty="0"/>
-          </a:p>
-        </p:txBody>
-      </p:sp>
-      <p:sp>
-        <p:nvSpPr>
-          <p:cNvPr id="15" name="PR node #3"/>
-          <p:cNvSpPr/>
-          <p:nvPr/>
-        </p:nvSpPr>
-        <p:spPr>
-          <a:xfrm>
-            <a:off x="3592286" y="1965960"/>
-            <a:ext cx="548640" cy="548640"/>
-          </a:xfrm>
-          <a:prstGeom prst="ellipse">
-            <a:avLst/>
-          </a:prstGeom>
-          <a:solidFill>
-            <a:schemeClr val="accent1"/>
-          </a:solidFill>
-          <a:ln w="12700">
-            <a:solidFill>
-              <a:schemeClr val="accent1"/>
-            </a:solidFill>
-            <a:prstDash val="solid"/>
-          </a:ln>
-        </p:spPr>
-      </p:sp>
-      <p:sp>
-        <p:nvSpPr>
-          <p:cNvPr id="16" name="PR num #3"/>
-          <p:cNvSpPr txBox="1"/>
-          <p:nvPr/>
-        </p:nvSpPr>
-        <p:spPr>
-          <a:xfrm>
-            <a:off x="3592286" y="1965960"/>
-            <a:ext cx="548640" cy="548640"/>
-          </a:xfrm>
-          <a:prstGeom prst="rect">
-            <a:avLst/>
-          </a:prstGeom>
-          <a:noFill/>
-          <a:ln/>
-        </p:spPr>
-        <p:txBody>
-          <a:bodyPr wrap="square" lIns="0" tIns="0" rIns="0" bIns="0" rtlCol="0" anchor="ctr"/>
-          <a:lstStyle/>
-          <a:p>
-            <a:pPr algn="ctr" indent="0" marL="0">
-              <a:buNone/>
-            </a:pPr>
-            <a:r>
-              <a:rPr lang="en-US" sz="1300" b="1" dirty="0">
-                <a:solidFill>
-                  <a:schemeClr val="bg1"/>
-                </a:solidFill>
-              </a:rPr>
-              <a:t>#3</a:t>
-            </a:r>
-            <a:endParaRPr lang="en-US" sz="1300" dirty="0"/>
-          </a:p>
-        </p:txBody>
-      </p:sp>
-      <p:sp>
-        <p:nvSpPr>
-          <p:cNvPr id="17" name="PR name #3"/>
-          <p:cNvSpPr txBox="1"/>
-          <p:nvPr/>
-        </p:nvSpPr>
-        <p:spPr>
-          <a:xfrm>
-            <a:off x="3226526" y="2606040"/>
-            <a:ext cx="1280160" cy="548640"/>
-          </a:xfrm>
-          <a:prstGeom prst="rect">
-            <a:avLst/>
-          </a:prstGeom>
-          <a:noFill/>
-          <a:ln/>
-        </p:spPr>
-        <p:txBody>
-          <a:bodyPr wrap="square" lIns="0" tIns="0" rIns="0" bIns="0" rtlCol="0" anchor="t"/>
-          <a:lstStyle/>
-          <a:p>
-            <a:pPr algn="ctr" indent="0" marL="0">
-              <a:buNone/>
-            </a:pPr>
-            <a:r>
-              <a:rPr lang="en-US" sz="1200" b="1" dirty="0">
-                <a:solidFill>
-                  <a:schemeClr val="tx1"/>
-                </a:solidFill>
-              </a:rPr>
-              <a:t>Exploration notebook</a:t>
-            </a:r>
-            <a:endParaRPr lang="en-US" sz="1200" dirty="0"/>
-          </a:p>
-        </p:txBody>
-      </p:sp>
-      <p:sp>
-        <p:nvSpPr>
-          <p:cNvPr id="18" name="PR node #4"/>
-          <p:cNvSpPr/>
-          <p:nvPr/>
-        </p:nvSpPr>
-        <p:spPr>
-          <a:xfrm>
-            <a:off x="5068389" y="1965960"/>
-            <a:ext cx="548640" cy="548640"/>
-          </a:xfrm>
-          <a:prstGeom prst="ellipse">
-            <a:avLst/>
-          </a:prstGeom>
-          <a:solidFill>
-            <a:schemeClr val="accent1"/>
-          </a:solidFill>
-          <a:ln w="12700">
-            <a:solidFill>
-              <a:schemeClr val="accent1"/>
-            </a:solidFill>
-            <a:prstDash val="solid"/>
-          </a:ln>
-        </p:spPr>
-      </p:sp>
-      <p:sp>
-        <p:nvSpPr>
-          <p:cNvPr id="19" name="PR num #4"/>
-          <p:cNvSpPr txBox="1"/>
-          <p:nvPr/>
-        </p:nvSpPr>
-        <p:spPr>
-          <a:xfrm>
-            <a:off x="5068389" y="1965960"/>
-            <a:ext cx="548640" cy="548640"/>
-          </a:xfrm>
-          <a:prstGeom prst="rect">
-            <a:avLst/>
-          </a:prstGeom>
-          <a:noFill/>
-          <a:ln/>
-        </p:spPr>
-        <p:txBody>
-          <a:bodyPr wrap="square" lIns="0" tIns="0" rIns="0" bIns="0" rtlCol="0" anchor="ctr"/>
-          <a:lstStyle/>
-          <a:p>
-            <a:pPr algn="ctr" indent="0" marL="0">
-              <a:buNone/>
-            </a:pPr>
-            <a:r>
-              <a:rPr lang="en-US" sz="1300" b="1" dirty="0">
-                <a:solidFill>
-                  <a:schemeClr val="bg1"/>
-                </a:solidFill>
-              </a:rPr>
-              <a:t>#4</a:t>
-            </a:r>
-            <a:endParaRPr lang="en-US" sz="1300" dirty="0"/>
-          </a:p>
-        </p:txBody>
-      </p:sp>
-      <p:sp>
-        <p:nvSpPr>
-          <p:cNvPr id="20" name="PR name #4"/>
-          <p:cNvSpPr txBox="1"/>
-          <p:nvPr/>
-        </p:nvSpPr>
-        <p:spPr>
-          <a:xfrm>
-            <a:off x="4702629" y="2606040"/>
-            <a:ext cx="1280160" cy="548640"/>
-          </a:xfrm>
-          <a:prstGeom prst="rect">
-            <a:avLst/>
-          </a:prstGeom>
-          <a:noFill/>
-          <a:ln/>
-        </p:spPr>
-        <p:txBody>
-          <a:bodyPr wrap="square" lIns="0" tIns="0" rIns="0" bIns="0" rtlCol="0" anchor="t"/>
-          <a:lstStyle/>
-          <a:p>
-            <a:pPr algn="ctr" indent="0" marL="0">
-              <a:buNone/>
-            </a:pPr>
-            <a:r>
-              <a:rPr lang="en-US" sz="1200" b="1" dirty="0">
-                <a:solidFill>
-                  <a:schemeClr val="tx1"/>
-                </a:solidFill>
-              </a:rPr>
-              <a:t>Pieces + keyword search</a:t>
-            </a:r>
-            <a:endParaRPr lang="en-US" sz="1200" dirty="0"/>
-          </a:p>
-        </p:txBody>
-      </p:sp>
-      <p:sp>
-        <p:nvSpPr>
-          <p:cNvPr id="21" name="PR node #5"/>
-          <p:cNvSpPr/>
-          <p:nvPr/>
-        </p:nvSpPr>
-        <p:spPr>
-          <a:xfrm>
-            <a:off x="6544491" y="1965960"/>
-            <a:ext cx="548640" cy="548640"/>
-          </a:xfrm>
-          <a:prstGeom prst="ellipse">
-            <a:avLst/>
-          </a:prstGeom>
-          <a:solidFill>
-            <a:schemeClr val="accent1"/>
-          </a:solidFill>
-          <a:ln w="12700">
-            <a:solidFill>
-              <a:schemeClr val="accent1"/>
-            </a:solidFill>
-            <a:prstDash val="solid"/>
-          </a:ln>
-        </p:spPr>
-      </p:sp>
-      <p:sp>
-        <p:nvSpPr>
-          <p:cNvPr id="22" name="PR num #5"/>
-          <p:cNvSpPr txBox="1"/>
-          <p:nvPr/>
-        </p:nvSpPr>
-        <p:spPr>
-          <a:xfrm>
-            <a:off x="6544491" y="1965960"/>
-            <a:ext cx="548640" cy="548640"/>
-          </a:xfrm>
-          <a:prstGeom prst="rect">
-            <a:avLst/>
-          </a:prstGeom>
-          <a:noFill/>
-          <a:ln/>
-        </p:spPr>
-        <p:txBody>
-          <a:bodyPr wrap="square" lIns="0" tIns="0" rIns="0" bIns="0" rtlCol="0" anchor="ctr"/>
-          <a:lstStyle/>
-          <a:p>
-            <a:pPr algn="ctr" indent="0" marL="0">
-              <a:buNone/>
-            </a:pPr>
-            <a:r>
-              <a:rPr lang="en-US" sz="1300" b="1" dirty="0">
-                <a:solidFill>
-                  <a:schemeClr val="bg1"/>
-                </a:solidFill>
-              </a:rPr>
-              <a:t>#5</a:t>
-            </a:r>
-            <a:endParaRPr lang="en-US" sz="1300" dirty="0"/>
-          </a:p>
-        </p:txBody>
-      </p:sp>
-      <p:sp>
-        <p:nvSpPr>
-          <p:cNvPr id="23" name="PR name #5"/>
-          <p:cNvSpPr txBox="1"/>
-          <p:nvPr/>
-        </p:nvSpPr>
-        <p:spPr>
-          <a:xfrm>
-            <a:off x="6178731" y="2606040"/>
-            <a:ext cx="1280160" cy="548640"/>
-          </a:xfrm>
-          <a:prstGeom prst="rect">
-            <a:avLst/>
-          </a:prstGeom>
-          <a:noFill/>
-          <a:ln/>
-        </p:spPr>
-        <p:txBody>
-          <a:bodyPr wrap="square" lIns="0" tIns="0" rIns="0" bIns="0" rtlCol="0" anchor="t"/>
-          <a:lstStyle/>
-          <a:p>
-            <a:pPr algn="ctr" indent="0" marL="0">
-              <a:buNone/>
-            </a:pPr>
-            <a:r>
-              <a:rPr lang="en-US" sz="1200" b="1" dirty="0">
-                <a:solidFill>
-                  <a:schemeClr val="tx1"/>
-                </a:solidFill>
-              </a:rPr>
-              <a:t>20 held-out questions</a:t>
-            </a:r>
-            <a:endParaRPr lang="en-US" sz="1200" dirty="0"/>
-          </a:p>
-        </p:txBody>
-      </p:sp>
-      <p:sp>
-        <p:nvSpPr>
-          <p:cNvPr id="24" name="PR node #6"/>
-          <p:cNvSpPr/>
-          <p:nvPr/>
-        </p:nvSpPr>
-        <p:spPr>
-          <a:xfrm>
-            <a:off x="8020594" y="1965960"/>
-            <a:ext cx="548640" cy="548640"/>
-          </a:xfrm>
-          <a:prstGeom prst="ellipse">
-            <a:avLst/>
-          </a:prstGeom>
-          <a:solidFill>
-            <a:schemeClr val="accent1"/>
-          </a:solidFill>
-          <a:ln w="12700">
-            <a:solidFill>
-              <a:schemeClr val="accent1"/>
-            </a:solidFill>
-            <a:prstDash val="solid"/>
-          </a:ln>
-        </p:spPr>
-      </p:sp>
-      <p:sp>
-        <p:nvSpPr>
-          <p:cNvPr id="25" name="PR num #6"/>
-          <p:cNvSpPr txBox="1"/>
-          <p:nvPr/>
-        </p:nvSpPr>
-        <p:spPr>
-          <a:xfrm>
-            <a:off x="8020594" y="1965960"/>
-            <a:ext cx="548640" cy="548640"/>
-          </a:xfrm>
-          <a:prstGeom prst="rect">
-            <a:avLst/>
-          </a:prstGeom>
-          <a:noFill/>
-          <a:ln/>
-        </p:spPr>
-        <p:txBody>
-          <a:bodyPr wrap="square" lIns="0" tIns="0" rIns="0" bIns="0" rtlCol="0" anchor="ctr"/>
-          <a:lstStyle/>
-          <a:p>
-            <a:pPr algn="ctr" indent="0" marL="0">
-              <a:buNone/>
-            </a:pPr>
-            <a:r>
-              <a:rPr lang="en-US" sz="1300" b="1" dirty="0">
-                <a:solidFill>
-                  <a:schemeClr val="bg1"/>
-                </a:solidFill>
-              </a:rPr>
-              <a:t>#6</a:t>
-            </a:r>
-            <a:endParaRPr lang="en-US" sz="1300" dirty="0"/>
-          </a:p>
-        </p:txBody>
-      </p:sp>
-      <p:sp>
-        <p:nvSpPr>
-          <p:cNvPr id="26" name="PR name #6"/>
-          <p:cNvSpPr txBox="1"/>
-          <p:nvPr/>
-        </p:nvSpPr>
-        <p:spPr>
-          <a:xfrm>
-            <a:off x="7654834" y="2606040"/>
-            <a:ext cx="1280160" cy="548640"/>
-          </a:xfrm>
-          <a:prstGeom prst="rect">
-            <a:avLst/>
-          </a:prstGeom>
-          <a:noFill/>
-          <a:ln/>
-        </p:spPr>
-        <p:txBody>
-          <a:bodyPr wrap="square" lIns="0" tIns="0" rIns="0" bIns="0" rtlCol="0" anchor="t"/>
-          <a:lstStyle/>
-          <a:p>
-            <a:pPr algn="ctr" indent="0" marL="0">
-              <a:buNone/>
-            </a:pPr>
-            <a:r>
-              <a:rPr lang="en-US" sz="1200" b="1" dirty="0">
-                <a:solidFill>
-                  <a:schemeClr val="tx1"/>
-                </a:solidFill>
-              </a:rPr>
-              <a:t>Exam machine (run_eval)</a:t>
-            </a:r>
-            <a:endParaRPr lang="en-US" sz="1200" dirty="0"/>
-          </a:p>
-        </p:txBody>
-      </p:sp>
-      <p:sp>
-        <p:nvSpPr>
-          <p:cNvPr id="27" name="PR node #7"/>
-          <p:cNvSpPr/>
-          <p:nvPr/>
-        </p:nvSpPr>
-        <p:spPr>
-          <a:xfrm>
-            <a:off x="9496697" y="1965960"/>
-            <a:ext cx="548640" cy="548640"/>
-          </a:xfrm>
-          <a:prstGeom prst="ellipse">
-            <a:avLst/>
-          </a:prstGeom>
-          <a:solidFill>
-            <a:schemeClr val="accent1"/>
-          </a:solidFill>
-          <a:ln w="12700">
-            <a:solidFill>
-              <a:schemeClr val="accent1"/>
-            </a:solidFill>
-            <a:prstDash val="solid"/>
-          </a:ln>
-        </p:spPr>
-      </p:sp>
-      <p:sp>
-        <p:nvSpPr>
-          <p:cNvPr id="28" name="PR num #7"/>
-          <p:cNvSpPr txBox="1"/>
-          <p:nvPr/>
-        </p:nvSpPr>
-        <p:spPr>
-          <a:xfrm>
-            <a:off x="9496697" y="1965960"/>
-            <a:ext cx="548640" cy="548640"/>
-          </a:xfrm>
-          <a:prstGeom prst="rect">
-            <a:avLst/>
-          </a:prstGeom>
-          <a:noFill/>
-          <a:ln/>
-        </p:spPr>
-        <p:txBody>
-          <a:bodyPr wrap="square" lIns="0" tIns="0" rIns="0" bIns="0" rtlCol="0" anchor="ctr"/>
-          <a:lstStyle/>
-          <a:p>
-            <a:pPr algn="ctr" indent="0" marL="0">
-              <a:buNone/>
-            </a:pPr>
-            <a:r>
-              <a:rPr lang="en-US" sz="1300" b="1" dirty="0">
-                <a:solidFill>
-                  <a:schemeClr val="bg1"/>
-                </a:solidFill>
-              </a:rPr>
-              <a:t>#7</a:t>
-            </a:r>
-            <a:endParaRPr lang="en-US" sz="1300" dirty="0"/>
-          </a:p>
-        </p:txBody>
-      </p:sp>
-      <p:sp>
-        <p:nvSpPr>
-          <p:cNvPr id="29" name="PR name #7"/>
-          <p:cNvSpPr txBox="1"/>
-          <p:nvPr/>
-        </p:nvSpPr>
-        <p:spPr>
-          <a:xfrm>
-            <a:off x="9130937" y="2606040"/>
-            <a:ext cx="1280160" cy="548640"/>
-          </a:xfrm>
-          <a:prstGeom prst="rect">
-            <a:avLst/>
-          </a:prstGeom>
-          <a:noFill/>
-          <a:ln/>
-        </p:spPr>
-        <p:txBody>
-          <a:bodyPr wrap="square" lIns="0" tIns="0" rIns="0" bIns="0" rtlCol="0" anchor="t"/>
-          <a:lstStyle/>
-          <a:p>
-            <a:pPr algn="ctr" indent="0" marL="0">
-              <a:buNone/>
-            </a:pPr>
-            <a:r>
-              <a:rPr lang="en-US" sz="1200" b="1" dirty="0">
-                <a:solidFill>
-                  <a:schemeClr val="tx1"/>
-                </a:solidFill>
-              </a:rPr>
-              <a:t>Dev / held-out reporting</a:t>
-            </a:r>
-            <a:endParaRPr lang="en-US" sz="1200" dirty="0"/>
-          </a:p>
-        </p:txBody>
-      </p:sp>
-      <p:sp>
-        <p:nvSpPr>
-          <p:cNvPr id="30" name="PR node #8"/>
-          <p:cNvSpPr/>
-          <p:nvPr/>
-        </p:nvSpPr>
-        <p:spPr>
-          <a:xfrm>
-            <a:off x="10972800" y="1965960"/>
-            <a:ext cx="548640" cy="548640"/>
-          </a:xfrm>
-          <a:prstGeom prst="ellipse">
-            <a:avLst/>
-          </a:prstGeom>
-          <a:solidFill>
-            <a:schemeClr val="accent2"/>
-          </a:solidFill>
-          <a:ln w="12700">
-            <a:solidFill>
-              <a:schemeClr val="accent2"/>
-            </a:solidFill>
-            <a:prstDash val="solid"/>
-          </a:ln>
-        </p:spPr>
-      </p:sp>
-      <p:sp>
-        <p:nvSpPr>
-          <p:cNvPr id="31" name="PR num #8"/>
-          <p:cNvSpPr txBox="1"/>
-          <p:nvPr/>
-        </p:nvSpPr>
-        <p:spPr>
-          <a:xfrm>
-            <a:off x="10972800" y="1965960"/>
-            <a:ext cx="548640" cy="548640"/>
-          </a:xfrm>
-          <a:prstGeom prst="rect">
-            <a:avLst/>
-          </a:prstGeom>
-          <a:noFill/>
-          <a:ln/>
-        </p:spPr>
-        <p:txBody>
-          <a:bodyPr wrap="square" lIns="0" tIns="0" rIns="0" bIns="0" rtlCol="0" anchor="ctr"/>
-          <a:lstStyle/>
-          <a:p>
-            <a:pPr algn="ctr" indent="0" marL="0">
-              <a:buNone/>
-            </a:pPr>
-            <a:r>
-              <a:rPr lang="en-US" sz="1300" b="1" dirty="0">
-                <a:solidFill>
-                  <a:schemeClr val="bg1"/>
-                </a:solidFill>
-              </a:rPr>
-              <a:t>#8</a:t>
-            </a:r>
-            <a:endParaRPr lang="en-US" sz="1300" dirty="0"/>
-          </a:p>
-        </p:txBody>
-      </p:sp>
-      <p:sp>
-        <p:nvSpPr>
-          <p:cNvPr id="32" name="PR name #8"/>
-          <p:cNvSpPr txBox="1"/>
-          <p:nvPr/>
-        </p:nvSpPr>
-        <p:spPr>
-          <a:xfrm>
-            <a:off x="10607040" y="2606040"/>
-            <a:ext cx="1280160" cy="548640"/>
-          </a:xfrm>
-          <a:prstGeom prst="rect">
-            <a:avLst/>
-          </a:prstGeom>
-          <a:noFill/>
-          <a:ln/>
-        </p:spPr>
-        <p:txBody>
-          <a:bodyPr wrap="square" lIns="0" tIns="0" rIns="0" bIns="0" rtlCol="0" anchor="t"/>
-          <a:lstStyle/>
-          <a:p>
-            <a:pPr algn="ctr" indent="0" marL="0">
-              <a:buNone/>
-            </a:pPr>
-            <a:r>
-              <a:rPr lang="en-US" sz="1200" b="1" dirty="0">
-                <a:solidFill>
-                  <a:schemeClr val="tx1"/>
-                </a:solidFill>
-              </a:rPr>
-              <a:t>Meaning search + hybrid</a:t>
-            </a:r>
-            <a:endParaRPr lang="en-US" sz="1200" dirty="0"/>
-          </a:p>
-        </p:txBody>
-      </p:sp>
-      <p:sp>
-        <p:nvSpPr>
-          <p:cNvPr id="33" name="Lesson 0"/>
-          <p:cNvSpPr/>
-          <p:nvPr/>
-        </p:nvSpPr>
-        <p:spPr>
-          <a:xfrm>
-            <a:off x="548640" y="3429000"/>
-            <a:ext cx="3520440" cy="2377440"/>
-          </a:xfrm>
-          <a:prstGeom prst="roundRect">
-            <a:avLst>
-              <a:gd name="adj" fmla="val 4615"/>
-            </a:avLst>
-          </a:prstGeom>
-          <a:solidFill>
-            <a:schemeClr val="bg2"/>
-          </a:solidFill>
-          <a:ln w="12700">
-            <a:solidFill>
-              <a:schemeClr val="bg2"/>
-            </a:solidFill>
-            <a:prstDash val="solid"/>
-          </a:ln>
-        </p:spPr>
-      </p:sp>
-      <p:sp>
-        <p:nvSpPr>
-          <p:cNvPr id="34" name="Lesson 0 dot"/>
-          <p:cNvSpPr/>
-          <p:nvPr/>
-        </p:nvSpPr>
-        <p:spPr>
-          <a:xfrm>
-            <a:off x="777240" y="3675888"/>
-            <a:ext cx="182880" cy="182880"/>
-          </a:xfrm>
-          <a:prstGeom prst="ellipse">
-            <a:avLst/>
-          </a:prstGeom>
-          <a:solidFill>
-            <a:schemeClr val="accent3"/>
-          </a:solidFill>
-          <a:ln w="12700">
-            <a:solidFill>
-              <a:schemeClr val="accent3"/>
-            </a:solidFill>
-            <a:prstDash val="solid"/>
-          </a:ln>
-        </p:spPr>
-      </p:sp>
-      <p:sp>
-        <p:nvSpPr>
-          <p:cNvPr id="35" name="Lesson 0 title"/>
-          <p:cNvSpPr txBox="1"/>
-          <p:nvPr/>
-        </p:nvSpPr>
-        <p:spPr>
-          <a:xfrm>
-            <a:off x="1051560" y="3584448"/>
-            <a:ext cx="2834640" cy="365760"/>
-          </a:xfrm>
-          <a:prstGeom prst="rect">
-            <a:avLst/>
-          </a:prstGeom>
-          <a:noFill/>
-          <a:ln/>
-        </p:spPr>
-        <p:txBody>
-          <a:bodyPr wrap="square" lIns="0" tIns="0" rIns="0" bIns="0" rtlCol="0" anchor="ctr"/>
-          <a:lstStyle/>
-          <a:p>
-            <a:pPr indent="0" marL="0">
-              <a:buNone/>
-            </a:pPr>
-            <a:r>
-              <a:rPr lang="en-US" sz="1700" b="1" dirty="0">
-                <a:solidFill>
-                  <a:schemeClr val="tx2"/>
-                </a:solidFill>
-              </a:rPr>
-              <a:t>Review before merging</a:t>
-            </a:r>
-            <a:endParaRPr lang="en-US" sz="1700" dirty="0"/>
-          </a:p>
-        </p:txBody>
-      </p:sp>
-      <p:sp>
-        <p:nvSpPr>
-          <p:cNvPr id="36" name="Lesson body 0"/>
-          <p:cNvSpPr txBox="1"/>
-          <p:nvPr/>
-        </p:nvSpPr>
-        <p:spPr>
-          <a:xfrm>
-            <a:off x="777240" y="4114800"/>
-            <a:ext cx="3108960" cy="1920240"/>
-          </a:xfrm>
-          <a:prstGeom prst="rect">
-            <a:avLst/>
-          </a:prstGeom>
-          <a:noFill/>
-          <a:ln/>
-        </p:spPr>
-        <p:txBody>
-          <a:bodyPr wrap="square" lIns="0" tIns="0" rIns="0" bIns="0" rtlCol="0" anchor="t"/>
-          <a:lstStyle/>
-          <a:p>
-            <a:pPr marL="177800" indent="-177800">
-              <a:spcAft>
-                <a:spcPts val="600"/>
-              </a:spcAft>
-              <a:buSzPct val="100000"/>
-              <a:buChar char="•"/>
-            </a:pPr>
-            <a:r>
-              <a:rPr lang="en-US" sz="1400" dirty="0">
-                <a:solidFill>
-                  <a:schemeClr val="tx1"/>
-                </a:solidFill>
-              </a:rPr>
-              <a:t>#2 and #4 were merged with no approval</a:t>
-            </a:r>
-            <a:endParaRPr lang="en-US" sz="1400" dirty="0"/>
-          </a:p>
-          <a:p>
-            <a:pPr marL="177800" indent="-177800">
-              <a:spcAft>
-                <a:spcPts val="600"/>
-              </a:spcAft>
-              <a:buSzPct val="100000"/>
-              <a:buChar char="•"/>
-            </a:pPr>
-            <a:r>
-              <a:rPr lang="en-US" sz="1400" dirty="0">
-                <a:solidFill>
-                  <a:schemeClr val="tx1"/>
-                </a:solidFill>
-              </a:rPr>
-              <a:t>Proposal: GitHub rule “1 approval required” (Paulin, 2 min)</a:t>
-            </a:r>
-            <a:endParaRPr lang="en-US" sz="1400" dirty="0"/>
-          </a:p>
-        </p:txBody>
-      </p:sp>
-      <p:sp>
-        <p:nvSpPr>
-          <p:cNvPr id="37" name="Lesson 1"/>
-          <p:cNvSpPr/>
-          <p:nvPr/>
-        </p:nvSpPr>
-        <p:spPr>
-          <a:xfrm>
-            <a:off x="4343400" y="3429000"/>
-            <a:ext cx="3520440" cy="2377440"/>
-          </a:xfrm>
-          <a:prstGeom prst="roundRect">
-            <a:avLst>
-              <a:gd name="adj" fmla="val 4615"/>
-            </a:avLst>
-          </a:prstGeom>
-          <a:solidFill>
-            <a:schemeClr val="bg2"/>
-          </a:solidFill>
-          <a:ln w="12700">
-            <a:solidFill>
-              <a:schemeClr val="bg2"/>
-            </a:solidFill>
-            <a:prstDash val="solid"/>
-          </a:ln>
-        </p:spPr>
-      </p:sp>
-      <p:sp>
-        <p:nvSpPr>
-          <p:cNvPr id="38" name="Lesson 1 dot"/>
-          <p:cNvSpPr/>
-          <p:nvPr/>
-        </p:nvSpPr>
-        <p:spPr>
-          <a:xfrm>
-            <a:off x="4572000" y="3675888"/>
-            <a:ext cx="182880" cy="182880"/>
-          </a:xfrm>
-          <a:prstGeom prst="ellipse">
-            <a:avLst/>
-          </a:prstGeom>
-          <a:solidFill>
-            <a:schemeClr val="accent2"/>
-          </a:solidFill>
-          <a:ln w="12700">
-            <a:solidFill>
-              <a:schemeClr val="accent2"/>
-            </a:solidFill>
-            <a:prstDash val="solid"/>
-          </a:ln>
-        </p:spPr>
-      </p:sp>
-      <p:sp>
-        <p:nvSpPr>
-          <p:cNvPr id="39" name="Lesson 1 title"/>
-          <p:cNvSpPr txBox="1"/>
-          <p:nvPr/>
-        </p:nvSpPr>
-        <p:spPr>
-          <a:xfrm>
-            <a:off x="4846320" y="3584448"/>
-            <a:ext cx="2834640" cy="365760"/>
-          </a:xfrm>
-          <a:prstGeom prst="rect">
-            <a:avLst/>
-          </a:prstGeom>
-          <a:noFill/>
-          <a:ln/>
-        </p:spPr>
-        <p:txBody>
-          <a:bodyPr wrap="square" lIns="0" tIns="0" rIns="0" bIns="0" rtlCol="0" anchor="ctr"/>
-          <a:lstStyle/>
-          <a:p>
-            <a:pPr indent="0" marL="0">
-              <a:buNone/>
-            </a:pPr>
-            <a:r>
-              <a:rPr lang="en-US" sz="1700" b="1" dirty="0">
-                <a:solidFill>
-                  <a:schemeClr val="tx2"/>
-                </a:solidFill>
-              </a:rPr>
-              <a:t>Re-run checks after merges</a:t>
-            </a:r>
-            <a:endParaRPr lang="en-US" sz="1700" dirty="0"/>
-          </a:p>
-        </p:txBody>
-      </p:sp>
-      <p:sp>
-        <p:nvSpPr>
-          <p:cNvPr id="40" name="Lesson body 1"/>
-          <p:cNvSpPr txBox="1"/>
-          <p:nvPr/>
-        </p:nvSpPr>
-        <p:spPr>
-          <a:xfrm>
-            <a:off x="4572000" y="4114800"/>
-            <a:ext cx="3108960" cy="1920240"/>
-          </a:xfrm>
-          <a:prstGeom prst="rect">
-            <a:avLst/>
-          </a:prstGeom>
-          <a:noFill/>
-          <a:ln/>
-        </p:spPr>
-        <p:txBody>
-          <a:bodyPr wrap="square" lIns="0" tIns="0" rIns="0" bIns="0" rtlCol="0" anchor="t"/>
-          <a:lstStyle/>
-          <a:p>
-            <a:pPr marL="177800" indent="-177800">
-              <a:spcAft>
-                <a:spcPts val="600"/>
-              </a:spcAft>
-              <a:buSzPct val="100000"/>
-              <a:buChar char="•"/>
-            </a:pPr>
-            <a:r>
-              <a:rPr lang="en-US" sz="1400" dirty="0">
-                <a:solidFill>
-                  <a:schemeClr val="tx1"/>
-                </a:solidFill>
-              </a:rPr>
-              <a:t>#5 and #6 were fine alone but clashed together: 1 check failed on main</a:t>
-            </a:r>
-            <a:endParaRPr lang="en-US" sz="1400" dirty="0"/>
-          </a:p>
-          <a:p>
-            <a:pPr marL="177800" indent="-177800">
-              <a:spcAft>
-                <a:spcPts val="600"/>
-              </a:spcAft>
-              <a:buSzPct val="100000"/>
-              <a:buChar char="•"/>
-            </a:pPr>
-            <a:r>
-              <a:rPr lang="en-US" sz="1400" dirty="0">
-                <a:solidFill>
-                  <a:schemeClr val="tx1"/>
-                </a:solidFill>
-              </a:rPr>
-              <a:t>Fixed by #7; now 35 checks pass on the PR #8 branch</a:t>
-            </a:r>
-            <a:endParaRPr lang="en-US" sz="1400" dirty="0"/>
-          </a:p>
-        </p:txBody>
-      </p:sp>
-      <p:sp>
-        <p:nvSpPr>
-          <p:cNvPr id="41" name="Lesson 2"/>
-          <p:cNvSpPr/>
-          <p:nvPr/>
-        </p:nvSpPr>
-        <p:spPr>
-          <a:xfrm>
-            <a:off x="8138160" y="3429000"/>
-            <a:ext cx="3520440" cy="2377440"/>
-          </a:xfrm>
-          <a:prstGeom prst="roundRect">
-            <a:avLst>
-              <a:gd name="adj" fmla="val 4615"/>
-            </a:avLst>
-          </a:prstGeom>
-          <a:solidFill>
-            <a:schemeClr val="bg2"/>
-          </a:solidFill>
-          <a:ln w="12700">
-            <a:solidFill>
-              <a:schemeClr val="bg2"/>
-            </a:solidFill>
-            <a:prstDash val="solid"/>
-          </a:ln>
-        </p:spPr>
-      </p:sp>
-      <p:sp>
-        <p:nvSpPr>
-          <p:cNvPr id="42" name="Lesson 2 dot"/>
-          <p:cNvSpPr/>
-          <p:nvPr/>
-        </p:nvSpPr>
-        <p:spPr>
-          <a:xfrm>
-            <a:off x="8366760" y="3675888"/>
-            <a:ext cx="182880" cy="182880"/>
-          </a:xfrm>
-          <a:prstGeom prst="ellipse">
-            <a:avLst/>
-          </a:prstGeom>
-          <a:solidFill>
-            <a:schemeClr val="accent1"/>
-          </a:solidFill>
-          <a:ln w="12700">
-            <a:solidFill>
-              <a:schemeClr val="accent1"/>
-            </a:solidFill>
-            <a:prstDash val="solid"/>
-          </a:ln>
-        </p:spPr>
-      </p:sp>
-      <p:sp>
-        <p:nvSpPr>
-          <p:cNvPr id="43" name="Lesson 2 title"/>
-          <p:cNvSpPr txBox="1"/>
-          <p:nvPr/>
-        </p:nvSpPr>
-        <p:spPr>
-          <a:xfrm>
-            <a:off x="8641080" y="3584448"/>
-            <a:ext cx="2834640" cy="365760"/>
-          </a:xfrm>
-          <a:prstGeom prst="rect">
-            <a:avLst/>
-          </a:prstGeom>
-          <a:noFill/>
-          <a:ln/>
-        </p:spPr>
-        <p:txBody>
-          <a:bodyPr wrap="square" lIns="0" tIns="0" rIns="0" bIns="0" rtlCol="0" anchor="ctr"/>
-          <a:lstStyle/>
-          <a:p>
-            <a:pPr indent="0" marL="0">
-              <a:buNone/>
-            </a:pPr>
-            <a:r>
-              <a:rPr lang="en-US" sz="1700" b="1" dirty="0">
-                <a:solidFill>
-                  <a:schemeClr val="tx2"/>
-                </a:solidFill>
-              </a:rPr>
-              <a:t>Keep the repo tidy</a:t>
-            </a:r>
-            <a:endParaRPr lang="en-US" sz="1700" dirty="0"/>
-          </a:p>
-        </p:txBody>
-      </p:sp>
-      <p:sp>
-        <p:nvSpPr>
-          <p:cNvPr id="44" name="Lesson body 2"/>
-          <p:cNvSpPr txBox="1"/>
-          <p:nvPr/>
-        </p:nvSpPr>
-        <p:spPr>
-          <a:xfrm>
-            <a:off x="8366760" y="4114800"/>
-            <a:ext cx="3108960" cy="1920240"/>
-          </a:xfrm>
-          <a:prstGeom prst="rect">
-            <a:avLst/>
-          </a:prstGeom>
-          <a:noFill/>
-          <a:ln/>
-        </p:spPr>
-        <p:txBody>
-          <a:bodyPr wrap="square" lIns="0" tIns="0" rIns="0" bIns="0" rtlCol="0" anchor="t"/>
-          <a:lstStyle/>
-          <a:p>
-            <a:pPr marL="177800" indent="-177800">
-              <a:spcAft>
-                <a:spcPts val="600"/>
-              </a:spcAft>
-              <a:buSzPct val="100000"/>
-              <a:buChar char="•"/>
-            </a:pPr>
-            <a:r>
-              <a:rPr lang="en-US" sz="1400" dirty="0">
-                <a:solidFill>
-                  <a:schemeClr val="tx1"/>
-                </a:solidFill>
-              </a:rPr>
-              <a:t>5 finished branches deleted</a:t>
-            </a:r>
-            <a:endParaRPr lang="en-US" sz="1400" dirty="0"/>
-          </a:p>
-          <a:p>
-            <a:pPr marL="177800" indent="-177800">
-              <a:spcAft>
-                <a:spcPts val="600"/>
-              </a:spcAft>
-              <a:buSzPct val="100000"/>
-              <a:buChar char="•"/>
-            </a:pPr>
-            <a:r>
-              <a:rPr lang="en-US" sz="1400" dirty="0">
-                <a:solidFill>
-                  <a:schemeClr val="tx1"/>
-                </a:solidFill>
-              </a:rPr>
-              <a:t>Tick “Automatically delete head branches” in Settings</a:t>
-            </a:r>
-            <a:endParaRPr lang="en-US" sz="1400" dirty="0"/>
-          </a:p>
-        </p:txBody>
-      </p:sp>
-      <p:sp>
-        <p:nvSpPr>
-          <p:cNvPr id="45" name="Work footnote"/>
-          <p:cNvSpPr txBox="1"/>
-          <p:nvPr/>
-        </p:nvSpPr>
-        <p:spPr>
-          <a:xfrm>
-            <a:off x="548640" y="6400800"/>
-            <a:ext cx="11064240" cy="274320"/>
-          </a:xfrm>
-          <a:prstGeom prst="rect">
-            <a:avLst/>
-          </a:prstGeom>
-          <a:noFill/>
-          <a:ln/>
-        </p:spPr>
-        <p:txBody>
-          <a:bodyPr wrap="square" lIns="0" tIns="0" rIns="0" bIns="0" rtlCol="0" anchor="ctr"/>
-          <a:lstStyle/>
-          <a:p>
-            <a:pPr indent="0" marL="0">
-              <a:buNone/>
-            </a:pPr>
-            <a:r>
-              <a:rPr lang="en-US" sz="1000" dirty="0">
-                <a:solidFill>
-                  <a:schemeClr val="accent6"/>
-                </a:solidFill>
-              </a:rPr>
-              <a:t>Open branches today: main, feat/dense-hybrid (PR #8), README_update (Léopold, no PR yet).</a:t>
             </a:r>
             <a:endParaRPr lang="en-US" sz="1000" dirty="0"/>
           </a:p>
@@ -12079,6 +11845,1500 @@
                   <a:schemeClr val="tx2"/>
                 </a:solidFill>
               </a:rPr>
+              <a:t>How we work: 8 pull requests, 35 automated checks</a:t>
+            </a:r>
+            <a:endParaRPr lang="en-US" sz="3000" dirty="0"/>
+          </a:p>
+        </p:txBody>
+      </p:sp>
+      <p:sp>
+        <p:nvSpPr>
+          <p:cNvPr id="3" name="Work subtitle"/>
+          <p:cNvSpPr txBox="1"/>
+          <p:nvPr/>
+        </p:nvSpPr>
+        <p:spPr>
+          <a:xfrm>
+            <a:off x="548640" y="1005840"/>
+            <a:ext cx="11064240" cy="320040"/>
+          </a:xfrm>
+          <a:prstGeom prst="rect">
+            <a:avLst/>
+          </a:prstGeom>
+          <a:noFill/>
+          <a:ln/>
+        </p:spPr>
+        <p:txBody>
+          <a:bodyPr wrap="square" lIns="0" tIns="0" rIns="0" bIns="0" rtlCol="0" anchor="ctr"/>
+          <a:lstStyle/>
+          <a:p>
+            <a:pPr indent="0" marL="0">
+              <a:buNone/>
+            </a:pPr>
+            <a:r>
+              <a:rPr lang="en-US" sz="1400" dirty="0">
+                <a:solidFill>
+                  <a:schemeClr val="accent6"/>
+                </a:solidFill>
+              </a:rPr>
+              <a:t>Every change goes through a pull request (PR): a proposal that a teammate reviews before it joins main</a:t>
+            </a:r>
+            <a:endParaRPr lang="en-US" sz="1400" dirty="0"/>
+          </a:p>
+        </p:txBody>
+      </p:sp>
+      <p:sp>
+        <p:nvSpPr>
+          <p:cNvPr id="4" name="PR legend dot Merged"/>
+          <p:cNvSpPr/>
+          <p:nvPr/>
+        </p:nvSpPr>
+        <p:spPr>
+          <a:xfrm>
+            <a:off x="10012680" y="429768"/>
+            <a:ext cx="137160" cy="137160"/>
+          </a:xfrm>
+          <a:prstGeom prst="ellipse">
+            <a:avLst/>
+          </a:prstGeom>
+          <a:solidFill>
+            <a:schemeClr val="accent1"/>
+          </a:solidFill>
+          <a:ln w="12700">
+            <a:solidFill>
+              <a:schemeClr val="accent1"/>
+            </a:solidFill>
+            <a:prstDash val="solid"/>
+          </a:ln>
+        </p:spPr>
+      </p:sp>
+      <p:sp>
+        <p:nvSpPr>
+          <p:cNvPr id="5" name="PR legend Merged"/>
+          <p:cNvSpPr txBox="1"/>
+          <p:nvPr/>
+        </p:nvSpPr>
+        <p:spPr>
+          <a:xfrm>
+            <a:off x="10222992" y="384048"/>
+            <a:ext cx="1737360" cy="228600"/>
+          </a:xfrm>
+          <a:prstGeom prst="rect">
+            <a:avLst/>
+          </a:prstGeom>
+          <a:noFill/>
+          <a:ln/>
+        </p:spPr>
+        <p:txBody>
+          <a:bodyPr wrap="square" lIns="0" tIns="0" rIns="0" bIns="0" rtlCol="0" anchor="ctr"/>
+          <a:lstStyle/>
+          <a:p>
+            <a:pPr indent="0" marL="0">
+              <a:buNone/>
+            </a:pPr>
+            <a:r>
+              <a:rPr lang="en-US" sz="1200" dirty="0">
+                <a:solidFill>
+                  <a:schemeClr val="tx1"/>
+                </a:solidFill>
+              </a:rPr>
+              <a:t>Merged</a:t>
+            </a:r>
+            <a:endParaRPr lang="en-US" sz="1200" dirty="0"/>
+          </a:p>
+        </p:txBody>
+      </p:sp>
+      <p:sp>
+        <p:nvSpPr>
+          <p:cNvPr id="6" name="PR legend dot Open"/>
+          <p:cNvSpPr/>
+          <p:nvPr/>
+        </p:nvSpPr>
+        <p:spPr>
+          <a:xfrm>
+            <a:off x="10012680" y="676656"/>
+            <a:ext cx="137160" cy="137160"/>
+          </a:xfrm>
+          <a:prstGeom prst="ellipse">
+            <a:avLst/>
+          </a:prstGeom>
+          <a:solidFill>
+            <a:schemeClr val="accent2"/>
+          </a:solidFill>
+          <a:ln w="12700">
+            <a:solidFill>
+              <a:schemeClr val="accent2"/>
+            </a:solidFill>
+            <a:prstDash val="solid"/>
+          </a:ln>
+        </p:spPr>
+      </p:sp>
+      <p:sp>
+        <p:nvSpPr>
+          <p:cNvPr id="7" name="PR legend Open"/>
+          <p:cNvSpPr txBox="1"/>
+          <p:nvPr/>
+        </p:nvSpPr>
+        <p:spPr>
+          <a:xfrm>
+            <a:off x="10222992" y="630936"/>
+            <a:ext cx="1737360" cy="228600"/>
+          </a:xfrm>
+          <a:prstGeom prst="rect">
+            <a:avLst/>
+          </a:prstGeom>
+          <a:noFill/>
+          <a:ln/>
+        </p:spPr>
+        <p:txBody>
+          <a:bodyPr wrap="square" lIns="0" tIns="0" rIns="0" bIns="0" rtlCol="0" anchor="ctr"/>
+          <a:lstStyle/>
+          <a:p>
+            <a:pPr indent="0" marL="0">
+              <a:buNone/>
+            </a:pPr>
+            <a:r>
+              <a:rPr lang="en-US" sz="1200" dirty="0">
+                <a:solidFill>
+                  <a:schemeClr val="tx1"/>
+                </a:solidFill>
+              </a:rPr>
+              <a:t>Open</a:t>
+            </a:r>
+            <a:endParaRPr lang="en-US" sz="1200" dirty="0"/>
+          </a:p>
+        </p:txBody>
+      </p:sp>
+      <p:sp>
+        <p:nvSpPr>
+          <p:cNvPr id="8" name="PR line"/>
+          <p:cNvSpPr/>
+          <p:nvPr/>
+        </p:nvSpPr>
+        <p:spPr>
+          <a:xfrm>
+            <a:off x="914400" y="2240280"/>
+            <a:ext cx="10332720" cy="0"/>
+          </a:xfrm>
+          <a:prstGeom prst="line">
+            <a:avLst/>
+          </a:prstGeom>
+          <a:noFill/>
+          <a:ln w="25400">
+            <a:solidFill>
+              <a:schemeClr val="accent4"/>
+            </a:solidFill>
+            <a:prstDash val="solid"/>
+          </a:ln>
+        </p:spPr>
+      </p:sp>
+      <p:sp>
+        <p:nvSpPr>
+          <p:cNvPr id="9" name="PR node #1"/>
+          <p:cNvSpPr/>
+          <p:nvPr/>
+        </p:nvSpPr>
+        <p:spPr>
+          <a:xfrm>
+            <a:off x="640080" y="1965960"/>
+            <a:ext cx="548640" cy="548640"/>
+          </a:xfrm>
+          <a:prstGeom prst="ellipse">
+            <a:avLst/>
+          </a:prstGeom>
+          <a:solidFill>
+            <a:schemeClr val="accent1"/>
+          </a:solidFill>
+          <a:ln w="12700">
+            <a:solidFill>
+              <a:schemeClr val="accent1"/>
+            </a:solidFill>
+            <a:prstDash val="solid"/>
+          </a:ln>
+        </p:spPr>
+      </p:sp>
+      <p:sp>
+        <p:nvSpPr>
+          <p:cNvPr id="10" name="PR num #1"/>
+          <p:cNvSpPr txBox="1"/>
+          <p:nvPr/>
+        </p:nvSpPr>
+        <p:spPr>
+          <a:xfrm>
+            <a:off x="640080" y="1965960"/>
+            <a:ext cx="548640" cy="548640"/>
+          </a:xfrm>
+          <a:prstGeom prst="rect">
+            <a:avLst/>
+          </a:prstGeom>
+          <a:noFill/>
+          <a:ln/>
+        </p:spPr>
+        <p:txBody>
+          <a:bodyPr wrap="square" lIns="0" tIns="0" rIns="0" bIns="0" rtlCol="0" anchor="ctr"/>
+          <a:lstStyle/>
+          <a:p>
+            <a:pPr algn="ctr" indent="0" marL="0">
+              <a:buNone/>
+            </a:pPr>
+            <a:r>
+              <a:rPr lang="en-US" sz="1300" b="1" dirty="0">
+                <a:solidFill>
+                  <a:schemeClr val="bg1"/>
+                </a:solidFill>
+              </a:rPr>
+              <a:t>#1</a:t>
+            </a:r>
+            <a:endParaRPr lang="en-US" sz="1300" dirty="0"/>
+          </a:p>
+        </p:txBody>
+      </p:sp>
+      <p:sp>
+        <p:nvSpPr>
+          <p:cNvPr id="11" name="PR name #1"/>
+          <p:cNvSpPr txBox="1"/>
+          <p:nvPr/>
+        </p:nvSpPr>
+        <p:spPr>
+          <a:xfrm>
+            <a:off x="274320" y="2606040"/>
+            <a:ext cx="1280160" cy="548640"/>
+          </a:xfrm>
+          <a:prstGeom prst="rect">
+            <a:avLst/>
+          </a:prstGeom>
+          <a:noFill/>
+          <a:ln/>
+        </p:spPr>
+        <p:txBody>
+          <a:bodyPr wrap="square" lIns="0" tIns="0" rIns="0" bIns="0" rtlCol="0" anchor="t"/>
+          <a:lstStyle/>
+          <a:p>
+            <a:pPr algn="ctr" indent="0" marL="0">
+              <a:buNone/>
+            </a:pPr>
+            <a:r>
+              <a:rPr lang="en-US" sz="1200" b="1" dirty="0">
+                <a:solidFill>
+                  <a:schemeClr val="tx1"/>
+                </a:solidFill>
+              </a:rPr>
+              <a:t>Data source &amp; licence</a:t>
+            </a:r>
+            <a:endParaRPr lang="en-US" sz="1200" dirty="0"/>
+          </a:p>
+        </p:txBody>
+      </p:sp>
+      <p:sp>
+        <p:nvSpPr>
+          <p:cNvPr id="12" name="PR node #2"/>
+          <p:cNvSpPr/>
+          <p:nvPr/>
+        </p:nvSpPr>
+        <p:spPr>
+          <a:xfrm>
+            <a:off x="2116183" y="1965960"/>
+            <a:ext cx="548640" cy="548640"/>
+          </a:xfrm>
+          <a:prstGeom prst="ellipse">
+            <a:avLst/>
+          </a:prstGeom>
+          <a:solidFill>
+            <a:schemeClr val="accent1"/>
+          </a:solidFill>
+          <a:ln w="12700">
+            <a:solidFill>
+              <a:schemeClr val="accent1"/>
+            </a:solidFill>
+            <a:prstDash val="solid"/>
+          </a:ln>
+        </p:spPr>
+      </p:sp>
+      <p:sp>
+        <p:nvSpPr>
+          <p:cNvPr id="13" name="PR num #2"/>
+          <p:cNvSpPr txBox="1"/>
+          <p:nvPr/>
+        </p:nvSpPr>
+        <p:spPr>
+          <a:xfrm>
+            <a:off x="2116183" y="1965960"/>
+            <a:ext cx="548640" cy="548640"/>
+          </a:xfrm>
+          <a:prstGeom prst="rect">
+            <a:avLst/>
+          </a:prstGeom>
+          <a:noFill/>
+          <a:ln/>
+        </p:spPr>
+        <p:txBody>
+          <a:bodyPr wrap="square" lIns="0" tIns="0" rIns="0" bIns="0" rtlCol="0" anchor="ctr"/>
+          <a:lstStyle/>
+          <a:p>
+            <a:pPr algn="ctr" indent="0" marL="0">
+              <a:buNone/>
+            </a:pPr>
+            <a:r>
+              <a:rPr lang="en-US" sz="1300" b="1" dirty="0">
+                <a:solidFill>
+                  <a:schemeClr val="bg1"/>
+                </a:solidFill>
+              </a:rPr>
+              <a:t>#2</a:t>
+            </a:r>
+            <a:endParaRPr lang="en-US" sz="1300" dirty="0"/>
+          </a:p>
+        </p:txBody>
+      </p:sp>
+      <p:sp>
+        <p:nvSpPr>
+          <p:cNvPr id="14" name="PR name #2"/>
+          <p:cNvSpPr txBox="1"/>
+          <p:nvPr/>
+        </p:nvSpPr>
+        <p:spPr>
+          <a:xfrm>
+            <a:off x="1750423" y="2606040"/>
+            <a:ext cx="1280160" cy="548640"/>
+          </a:xfrm>
+          <a:prstGeom prst="rect">
+            <a:avLst/>
+          </a:prstGeom>
+          <a:noFill/>
+          <a:ln/>
+        </p:spPr>
+        <p:txBody>
+          <a:bodyPr wrap="square" lIns="0" tIns="0" rIns="0" bIns="0" rtlCol="0" anchor="t"/>
+          <a:lstStyle/>
+          <a:p>
+            <a:pPr algn="ctr" indent="0" marL="0">
+              <a:buNone/>
+            </a:pPr>
+            <a:r>
+              <a:rPr lang="en-US" sz="1200" b="1" dirty="0">
+                <a:solidFill>
+                  <a:schemeClr val="tx1"/>
+                </a:solidFill>
+              </a:rPr>
+              <a:t>Dashboard &amp; slides</a:t>
+            </a:r>
+            <a:endParaRPr lang="en-US" sz="1200" dirty="0"/>
+          </a:p>
+        </p:txBody>
+      </p:sp>
+      <p:sp>
+        <p:nvSpPr>
+          <p:cNvPr id="15" name="PR node #3"/>
+          <p:cNvSpPr/>
+          <p:nvPr/>
+        </p:nvSpPr>
+        <p:spPr>
+          <a:xfrm>
+            <a:off x="3592286" y="1965960"/>
+            <a:ext cx="548640" cy="548640"/>
+          </a:xfrm>
+          <a:prstGeom prst="ellipse">
+            <a:avLst/>
+          </a:prstGeom>
+          <a:solidFill>
+            <a:schemeClr val="accent1"/>
+          </a:solidFill>
+          <a:ln w="12700">
+            <a:solidFill>
+              <a:schemeClr val="accent1"/>
+            </a:solidFill>
+            <a:prstDash val="solid"/>
+          </a:ln>
+        </p:spPr>
+      </p:sp>
+      <p:sp>
+        <p:nvSpPr>
+          <p:cNvPr id="16" name="PR num #3"/>
+          <p:cNvSpPr txBox="1"/>
+          <p:nvPr/>
+        </p:nvSpPr>
+        <p:spPr>
+          <a:xfrm>
+            <a:off x="3592286" y="1965960"/>
+            <a:ext cx="548640" cy="548640"/>
+          </a:xfrm>
+          <a:prstGeom prst="rect">
+            <a:avLst/>
+          </a:prstGeom>
+          <a:noFill/>
+          <a:ln/>
+        </p:spPr>
+        <p:txBody>
+          <a:bodyPr wrap="square" lIns="0" tIns="0" rIns="0" bIns="0" rtlCol="0" anchor="ctr"/>
+          <a:lstStyle/>
+          <a:p>
+            <a:pPr algn="ctr" indent="0" marL="0">
+              <a:buNone/>
+            </a:pPr>
+            <a:r>
+              <a:rPr lang="en-US" sz="1300" b="1" dirty="0">
+                <a:solidFill>
+                  <a:schemeClr val="bg1"/>
+                </a:solidFill>
+              </a:rPr>
+              <a:t>#3</a:t>
+            </a:r>
+            <a:endParaRPr lang="en-US" sz="1300" dirty="0"/>
+          </a:p>
+        </p:txBody>
+      </p:sp>
+      <p:sp>
+        <p:nvSpPr>
+          <p:cNvPr id="17" name="PR name #3"/>
+          <p:cNvSpPr txBox="1"/>
+          <p:nvPr/>
+        </p:nvSpPr>
+        <p:spPr>
+          <a:xfrm>
+            <a:off x="3226526" y="2606040"/>
+            <a:ext cx="1280160" cy="548640"/>
+          </a:xfrm>
+          <a:prstGeom prst="rect">
+            <a:avLst/>
+          </a:prstGeom>
+          <a:noFill/>
+          <a:ln/>
+        </p:spPr>
+        <p:txBody>
+          <a:bodyPr wrap="square" lIns="0" tIns="0" rIns="0" bIns="0" rtlCol="0" anchor="t"/>
+          <a:lstStyle/>
+          <a:p>
+            <a:pPr algn="ctr" indent="0" marL="0">
+              <a:buNone/>
+            </a:pPr>
+            <a:r>
+              <a:rPr lang="en-US" sz="1200" b="1" dirty="0">
+                <a:solidFill>
+                  <a:schemeClr val="tx1"/>
+                </a:solidFill>
+              </a:rPr>
+              <a:t>Exploration notebook</a:t>
+            </a:r>
+            <a:endParaRPr lang="en-US" sz="1200" dirty="0"/>
+          </a:p>
+        </p:txBody>
+      </p:sp>
+      <p:sp>
+        <p:nvSpPr>
+          <p:cNvPr id="18" name="PR node #4"/>
+          <p:cNvSpPr/>
+          <p:nvPr/>
+        </p:nvSpPr>
+        <p:spPr>
+          <a:xfrm>
+            <a:off x="5068389" y="1965960"/>
+            <a:ext cx="548640" cy="548640"/>
+          </a:xfrm>
+          <a:prstGeom prst="ellipse">
+            <a:avLst/>
+          </a:prstGeom>
+          <a:solidFill>
+            <a:schemeClr val="accent1"/>
+          </a:solidFill>
+          <a:ln w="12700">
+            <a:solidFill>
+              <a:schemeClr val="accent1"/>
+            </a:solidFill>
+            <a:prstDash val="solid"/>
+          </a:ln>
+        </p:spPr>
+      </p:sp>
+      <p:sp>
+        <p:nvSpPr>
+          <p:cNvPr id="19" name="PR num #4"/>
+          <p:cNvSpPr txBox="1"/>
+          <p:nvPr/>
+        </p:nvSpPr>
+        <p:spPr>
+          <a:xfrm>
+            <a:off x="5068389" y="1965960"/>
+            <a:ext cx="548640" cy="548640"/>
+          </a:xfrm>
+          <a:prstGeom prst="rect">
+            <a:avLst/>
+          </a:prstGeom>
+          <a:noFill/>
+          <a:ln/>
+        </p:spPr>
+        <p:txBody>
+          <a:bodyPr wrap="square" lIns="0" tIns="0" rIns="0" bIns="0" rtlCol="0" anchor="ctr"/>
+          <a:lstStyle/>
+          <a:p>
+            <a:pPr algn="ctr" indent="0" marL="0">
+              <a:buNone/>
+            </a:pPr>
+            <a:r>
+              <a:rPr lang="en-US" sz="1300" b="1" dirty="0">
+                <a:solidFill>
+                  <a:schemeClr val="bg1"/>
+                </a:solidFill>
+              </a:rPr>
+              <a:t>#4</a:t>
+            </a:r>
+            <a:endParaRPr lang="en-US" sz="1300" dirty="0"/>
+          </a:p>
+        </p:txBody>
+      </p:sp>
+      <p:sp>
+        <p:nvSpPr>
+          <p:cNvPr id="20" name="PR name #4"/>
+          <p:cNvSpPr txBox="1"/>
+          <p:nvPr/>
+        </p:nvSpPr>
+        <p:spPr>
+          <a:xfrm>
+            <a:off x="4702629" y="2606040"/>
+            <a:ext cx="1280160" cy="548640"/>
+          </a:xfrm>
+          <a:prstGeom prst="rect">
+            <a:avLst/>
+          </a:prstGeom>
+          <a:noFill/>
+          <a:ln/>
+        </p:spPr>
+        <p:txBody>
+          <a:bodyPr wrap="square" lIns="0" tIns="0" rIns="0" bIns="0" rtlCol="0" anchor="t"/>
+          <a:lstStyle/>
+          <a:p>
+            <a:pPr algn="ctr" indent="0" marL="0">
+              <a:buNone/>
+            </a:pPr>
+            <a:r>
+              <a:rPr lang="en-US" sz="1200" b="1" dirty="0">
+                <a:solidFill>
+                  <a:schemeClr val="tx1"/>
+                </a:solidFill>
+              </a:rPr>
+              <a:t>Pieces + keyword search</a:t>
+            </a:r>
+            <a:endParaRPr lang="en-US" sz="1200" dirty="0"/>
+          </a:p>
+        </p:txBody>
+      </p:sp>
+      <p:sp>
+        <p:nvSpPr>
+          <p:cNvPr id="21" name="PR node #5"/>
+          <p:cNvSpPr/>
+          <p:nvPr/>
+        </p:nvSpPr>
+        <p:spPr>
+          <a:xfrm>
+            <a:off x="6544491" y="1965960"/>
+            <a:ext cx="548640" cy="548640"/>
+          </a:xfrm>
+          <a:prstGeom prst="ellipse">
+            <a:avLst/>
+          </a:prstGeom>
+          <a:solidFill>
+            <a:schemeClr val="accent1"/>
+          </a:solidFill>
+          <a:ln w="12700">
+            <a:solidFill>
+              <a:schemeClr val="accent1"/>
+            </a:solidFill>
+            <a:prstDash val="solid"/>
+          </a:ln>
+        </p:spPr>
+      </p:sp>
+      <p:sp>
+        <p:nvSpPr>
+          <p:cNvPr id="22" name="PR num #5"/>
+          <p:cNvSpPr txBox="1"/>
+          <p:nvPr/>
+        </p:nvSpPr>
+        <p:spPr>
+          <a:xfrm>
+            <a:off x="6544491" y="1965960"/>
+            <a:ext cx="548640" cy="548640"/>
+          </a:xfrm>
+          <a:prstGeom prst="rect">
+            <a:avLst/>
+          </a:prstGeom>
+          <a:noFill/>
+          <a:ln/>
+        </p:spPr>
+        <p:txBody>
+          <a:bodyPr wrap="square" lIns="0" tIns="0" rIns="0" bIns="0" rtlCol="0" anchor="ctr"/>
+          <a:lstStyle/>
+          <a:p>
+            <a:pPr algn="ctr" indent="0" marL="0">
+              <a:buNone/>
+            </a:pPr>
+            <a:r>
+              <a:rPr lang="en-US" sz="1300" b="1" dirty="0">
+                <a:solidFill>
+                  <a:schemeClr val="bg1"/>
+                </a:solidFill>
+              </a:rPr>
+              <a:t>#5</a:t>
+            </a:r>
+            <a:endParaRPr lang="en-US" sz="1300" dirty="0"/>
+          </a:p>
+        </p:txBody>
+      </p:sp>
+      <p:sp>
+        <p:nvSpPr>
+          <p:cNvPr id="23" name="PR name #5"/>
+          <p:cNvSpPr txBox="1"/>
+          <p:nvPr/>
+        </p:nvSpPr>
+        <p:spPr>
+          <a:xfrm>
+            <a:off x="6178731" y="2606040"/>
+            <a:ext cx="1280160" cy="548640"/>
+          </a:xfrm>
+          <a:prstGeom prst="rect">
+            <a:avLst/>
+          </a:prstGeom>
+          <a:noFill/>
+          <a:ln/>
+        </p:spPr>
+        <p:txBody>
+          <a:bodyPr wrap="square" lIns="0" tIns="0" rIns="0" bIns="0" rtlCol="0" anchor="t"/>
+          <a:lstStyle/>
+          <a:p>
+            <a:pPr algn="ctr" indent="0" marL="0">
+              <a:buNone/>
+            </a:pPr>
+            <a:r>
+              <a:rPr lang="en-US" sz="1200" b="1" dirty="0">
+                <a:solidFill>
+                  <a:schemeClr val="tx1"/>
+                </a:solidFill>
+              </a:rPr>
+              <a:t>20 held-out questions</a:t>
+            </a:r>
+            <a:endParaRPr lang="en-US" sz="1200" dirty="0"/>
+          </a:p>
+        </p:txBody>
+      </p:sp>
+      <p:sp>
+        <p:nvSpPr>
+          <p:cNvPr id="24" name="PR node #6"/>
+          <p:cNvSpPr/>
+          <p:nvPr/>
+        </p:nvSpPr>
+        <p:spPr>
+          <a:xfrm>
+            <a:off x="8020594" y="1965960"/>
+            <a:ext cx="548640" cy="548640"/>
+          </a:xfrm>
+          <a:prstGeom prst="ellipse">
+            <a:avLst/>
+          </a:prstGeom>
+          <a:solidFill>
+            <a:schemeClr val="accent1"/>
+          </a:solidFill>
+          <a:ln w="12700">
+            <a:solidFill>
+              <a:schemeClr val="accent1"/>
+            </a:solidFill>
+            <a:prstDash val="solid"/>
+          </a:ln>
+        </p:spPr>
+      </p:sp>
+      <p:sp>
+        <p:nvSpPr>
+          <p:cNvPr id="25" name="PR num #6"/>
+          <p:cNvSpPr txBox="1"/>
+          <p:nvPr/>
+        </p:nvSpPr>
+        <p:spPr>
+          <a:xfrm>
+            <a:off x="8020594" y="1965960"/>
+            <a:ext cx="548640" cy="548640"/>
+          </a:xfrm>
+          <a:prstGeom prst="rect">
+            <a:avLst/>
+          </a:prstGeom>
+          <a:noFill/>
+          <a:ln/>
+        </p:spPr>
+        <p:txBody>
+          <a:bodyPr wrap="square" lIns="0" tIns="0" rIns="0" bIns="0" rtlCol="0" anchor="ctr"/>
+          <a:lstStyle/>
+          <a:p>
+            <a:pPr algn="ctr" indent="0" marL="0">
+              <a:buNone/>
+            </a:pPr>
+            <a:r>
+              <a:rPr lang="en-US" sz="1300" b="1" dirty="0">
+                <a:solidFill>
+                  <a:schemeClr val="bg1"/>
+                </a:solidFill>
+              </a:rPr>
+              <a:t>#6</a:t>
+            </a:r>
+            <a:endParaRPr lang="en-US" sz="1300" dirty="0"/>
+          </a:p>
+        </p:txBody>
+      </p:sp>
+      <p:sp>
+        <p:nvSpPr>
+          <p:cNvPr id="26" name="PR name #6"/>
+          <p:cNvSpPr txBox="1"/>
+          <p:nvPr/>
+        </p:nvSpPr>
+        <p:spPr>
+          <a:xfrm>
+            <a:off x="7654834" y="2606040"/>
+            <a:ext cx="1280160" cy="548640"/>
+          </a:xfrm>
+          <a:prstGeom prst="rect">
+            <a:avLst/>
+          </a:prstGeom>
+          <a:noFill/>
+          <a:ln/>
+        </p:spPr>
+        <p:txBody>
+          <a:bodyPr wrap="square" lIns="0" tIns="0" rIns="0" bIns="0" rtlCol="0" anchor="t"/>
+          <a:lstStyle/>
+          <a:p>
+            <a:pPr algn="ctr" indent="0" marL="0">
+              <a:buNone/>
+            </a:pPr>
+            <a:r>
+              <a:rPr lang="en-US" sz="1200" b="1" dirty="0">
+                <a:solidFill>
+                  <a:schemeClr val="tx1"/>
+                </a:solidFill>
+              </a:rPr>
+              <a:t>Exam machine (run_eval)</a:t>
+            </a:r>
+            <a:endParaRPr lang="en-US" sz="1200" dirty="0"/>
+          </a:p>
+        </p:txBody>
+      </p:sp>
+      <p:sp>
+        <p:nvSpPr>
+          <p:cNvPr id="27" name="PR node #7"/>
+          <p:cNvSpPr/>
+          <p:nvPr/>
+        </p:nvSpPr>
+        <p:spPr>
+          <a:xfrm>
+            <a:off x="9496697" y="1965960"/>
+            <a:ext cx="548640" cy="548640"/>
+          </a:xfrm>
+          <a:prstGeom prst="ellipse">
+            <a:avLst/>
+          </a:prstGeom>
+          <a:solidFill>
+            <a:schemeClr val="accent1"/>
+          </a:solidFill>
+          <a:ln w="12700">
+            <a:solidFill>
+              <a:schemeClr val="accent1"/>
+            </a:solidFill>
+            <a:prstDash val="solid"/>
+          </a:ln>
+        </p:spPr>
+      </p:sp>
+      <p:sp>
+        <p:nvSpPr>
+          <p:cNvPr id="28" name="PR num #7"/>
+          <p:cNvSpPr txBox="1"/>
+          <p:nvPr/>
+        </p:nvSpPr>
+        <p:spPr>
+          <a:xfrm>
+            <a:off x="9496697" y="1965960"/>
+            <a:ext cx="548640" cy="548640"/>
+          </a:xfrm>
+          <a:prstGeom prst="rect">
+            <a:avLst/>
+          </a:prstGeom>
+          <a:noFill/>
+          <a:ln/>
+        </p:spPr>
+        <p:txBody>
+          <a:bodyPr wrap="square" lIns="0" tIns="0" rIns="0" bIns="0" rtlCol="0" anchor="ctr"/>
+          <a:lstStyle/>
+          <a:p>
+            <a:pPr algn="ctr" indent="0" marL="0">
+              <a:buNone/>
+            </a:pPr>
+            <a:r>
+              <a:rPr lang="en-US" sz="1300" b="1" dirty="0">
+                <a:solidFill>
+                  <a:schemeClr val="bg1"/>
+                </a:solidFill>
+              </a:rPr>
+              <a:t>#7</a:t>
+            </a:r>
+            <a:endParaRPr lang="en-US" sz="1300" dirty="0"/>
+          </a:p>
+        </p:txBody>
+      </p:sp>
+      <p:sp>
+        <p:nvSpPr>
+          <p:cNvPr id="29" name="PR name #7"/>
+          <p:cNvSpPr txBox="1"/>
+          <p:nvPr/>
+        </p:nvSpPr>
+        <p:spPr>
+          <a:xfrm>
+            <a:off x="9130937" y="2606040"/>
+            <a:ext cx="1280160" cy="548640"/>
+          </a:xfrm>
+          <a:prstGeom prst="rect">
+            <a:avLst/>
+          </a:prstGeom>
+          <a:noFill/>
+          <a:ln/>
+        </p:spPr>
+        <p:txBody>
+          <a:bodyPr wrap="square" lIns="0" tIns="0" rIns="0" bIns="0" rtlCol="0" anchor="t"/>
+          <a:lstStyle/>
+          <a:p>
+            <a:pPr algn="ctr" indent="0" marL="0">
+              <a:buNone/>
+            </a:pPr>
+            <a:r>
+              <a:rPr lang="en-US" sz="1200" b="1" dirty="0">
+                <a:solidFill>
+                  <a:schemeClr val="tx1"/>
+                </a:solidFill>
+              </a:rPr>
+              <a:t>Dev / held-out reporting</a:t>
+            </a:r>
+            <a:endParaRPr lang="en-US" sz="1200" dirty="0"/>
+          </a:p>
+        </p:txBody>
+      </p:sp>
+      <p:sp>
+        <p:nvSpPr>
+          <p:cNvPr id="30" name="PR node #8"/>
+          <p:cNvSpPr/>
+          <p:nvPr/>
+        </p:nvSpPr>
+        <p:spPr>
+          <a:xfrm>
+            <a:off x="10972800" y="1965960"/>
+            <a:ext cx="548640" cy="548640"/>
+          </a:xfrm>
+          <a:prstGeom prst="ellipse">
+            <a:avLst/>
+          </a:prstGeom>
+          <a:solidFill>
+            <a:schemeClr val="accent2"/>
+          </a:solidFill>
+          <a:ln w="12700">
+            <a:solidFill>
+              <a:schemeClr val="accent2"/>
+            </a:solidFill>
+            <a:prstDash val="solid"/>
+          </a:ln>
+        </p:spPr>
+      </p:sp>
+      <p:sp>
+        <p:nvSpPr>
+          <p:cNvPr id="31" name="PR num #8"/>
+          <p:cNvSpPr txBox="1"/>
+          <p:nvPr/>
+        </p:nvSpPr>
+        <p:spPr>
+          <a:xfrm>
+            <a:off x="10972800" y="1965960"/>
+            <a:ext cx="548640" cy="548640"/>
+          </a:xfrm>
+          <a:prstGeom prst="rect">
+            <a:avLst/>
+          </a:prstGeom>
+          <a:noFill/>
+          <a:ln/>
+        </p:spPr>
+        <p:txBody>
+          <a:bodyPr wrap="square" lIns="0" tIns="0" rIns="0" bIns="0" rtlCol="0" anchor="ctr"/>
+          <a:lstStyle/>
+          <a:p>
+            <a:pPr algn="ctr" indent="0" marL="0">
+              <a:buNone/>
+            </a:pPr>
+            <a:r>
+              <a:rPr lang="en-US" sz="1300" b="1" dirty="0">
+                <a:solidFill>
+                  <a:schemeClr val="bg1"/>
+                </a:solidFill>
+              </a:rPr>
+              <a:t>#8</a:t>
+            </a:r>
+            <a:endParaRPr lang="en-US" sz="1300" dirty="0"/>
+          </a:p>
+        </p:txBody>
+      </p:sp>
+      <p:sp>
+        <p:nvSpPr>
+          <p:cNvPr id="32" name="PR name #8"/>
+          <p:cNvSpPr txBox="1"/>
+          <p:nvPr/>
+        </p:nvSpPr>
+        <p:spPr>
+          <a:xfrm>
+            <a:off x="10607040" y="2606040"/>
+            <a:ext cx="1280160" cy="548640"/>
+          </a:xfrm>
+          <a:prstGeom prst="rect">
+            <a:avLst/>
+          </a:prstGeom>
+          <a:noFill/>
+          <a:ln/>
+        </p:spPr>
+        <p:txBody>
+          <a:bodyPr wrap="square" lIns="0" tIns="0" rIns="0" bIns="0" rtlCol="0" anchor="t"/>
+          <a:lstStyle/>
+          <a:p>
+            <a:pPr algn="ctr" indent="0" marL="0">
+              <a:buNone/>
+            </a:pPr>
+            <a:r>
+              <a:rPr lang="en-US" sz="1200" b="1" dirty="0">
+                <a:solidFill>
+                  <a:schemeClr val="tx1"/>
+                </a:solidFill>
+              </a:rPr>
+              <a:t>Meaning search + hybrid</a:t>
+            </a:r>
+            <a:endParaRPr lang="en-US" sz="1200" dirty="0"/>
+          </a:p>
+        </p:txBody>
+      </p:sp>
+      <p:sp>
+        <p:nvSpPr>
+          <p:cNvPr id="33" name="Lesson 0"/>
+          <p:cNvSpPr/>
+          <p:nvPr/>
+        </p:nvSpPr>
+        <p:spPr>
+          <a:xfrm>
+            <a:off x="548640" y="3429000"/>
+            <a:ext cx="3520440" cy="2377440"/>
+          </a:xfrm>
+          <a:prstGeom prst="roundRect">
+            <a:avLst>
+              <a:gd name="adj" fmla="val 4615"/>
+            </a:avLst>
+          </a:prstGeom>
+          <a:solidFill>
+            <a:schemeClr val="bg2"/>
+          </a:solidFill>
+          <a:ln w="12700">
+            <a:solidFill>
+              <a:schemeClr val="bg2"/>
+            </a:solidFill>
+            <a:prstDash val="solid"/>
+          </a:ln>
+        </p:spPr>
+      </p:sp>
+      <p:sp>
+        <p:nvSpPr>
+          <p:cNvPr id="34" name="Lesson 0 dot"/>
+          <p:cNvSpPr/>
+          <p:nvPr/>
+        </p:nvSpPr>
+        <p:spPr>
+          <a:xfrm>
+            <a:off x="777240" y="3675888"/>
+            <a:ext cx="182880" cy="182880"/>
+          </a:xfrm>
+          <a:prstGeom prst="ellipse">
+            <a:avLst/>
+          </a:prstGeom>
+          <a:solidFill>
+            <a:schemeClr val="accent3"/>
+          </a:solidFill>
+          <a:ln w="12700">
+            <a:solidFill>
+              <a:schemeClr val="accent3"/>
+            </a:solidFill>
+            <a:prstDash val="solid"/>
+          </a:ln>
+        </p:spPr>
+      </p:sp>
+      <p:sp>
+        <p:nvSpPr>
+          <p:cNvPr id="35" name="Lesson 0 title"/>
+          <p:cNvSpPr txBox="1"/>
+          <p:nvPr/>
+        </p:nvSpPr>
+        <p:spPr>
+          <a:xfrm>
+            <a:off x="1051560" y="3584448"/>
+            <a:ext cx="2834640" cy="365760"/>
+          </a:xfrm>
+          <a:prstGeom prst="rect">
+            <a:avLst/>
+          </a:prstGeom>
+          <a:noFill/>
+          <a:ln/>
+        </p:spPr>
+        <p:txBody>
+          <a:bodyPr wrap="square" lIns="0" tIns="0" rIns="0" bIns="0" rtlCol="0" anchor="ctr"/>
+          <a:lstStyle/>
+          <a:p>
+            <a:pPr indent="0" marL="0">
+              <a:buNone/>
+            </a:pPr>
+            <a:r>
+              <a:rPr lang="en-US" sz="1700" b="1" dirty="0">
+                <a:solidFill>
+                  <a:schemeClr val="tx2"/>
+                </a:solidFill>
+              </a:rPr>
+              <a:t>Review before merging</a:t>
+            </a:r>
+            <a:endParaRPr lang="en-US" sz="1700" dirty="0"/>
+          </a:p>
+        </p:txBody>
+      </p:sp>
+      <p:sp>
+        <p:nvSpPr>
+          <p:cNvPr id="36" name="Lesson body 0"/>
+          <p:cNvSpPr txBox="1"/>
+          <p:nvPr/>
+        </p:nvSpPr>
+        <p:spPr>
+          <a:xfrm>
+            <a:off x="777240" y="4114800"/>
+            <a:ext cx="3108960" cy="1920240"/>
+          </a:xfrm>
+          <a:prstGeom prst="rect">
+            <a:avLst/>
+          </a:prstGeom>
+          <a:noFill/>
+          <a:ln/>
+        </p:spPr>
+        <p:txBody>
+          <a:bodyPr wrap="square" lIns="0" tIns="0" rIns="0" bIns="0" rtlCol="0" anchor="t"/>
+          <a:lstStyle/>
+          <a:p>
+            <a:pPr marL="177800" indent="-177800">
+              <a:spcAft>
+                <a:spcPts val="600"/>
+              </a:spcAft>
+              <a:buSzPct val="100000"/>
+              <a:buChar char="•"/>
+            </a:pPr>
+            <a:r>
+              <a:rPr lang="en-US" sz="1400" dirty="0">
+                <a:solidFill>
+                  <a:schemeClr val="tx1"/>
+                </a:solidFill>
+              </a:rPr>
+              <a:t>#2 and #4 were merged with no approval</a:t>
+            </a:r>
+            <a:endParaRPr lang="en-US" sz="1400" dirty="0"/>
+          </a:p>
+          <a:p>
+            <a:pPr marL="177800" indent="-177800">
+              <a:spcAft>
+                <a:spcPts val="600"/>
+              </a:spcAft>
+              <a:buSzPct val="100000"/>
+              <a:buChar char="•"/>
+            </a:pPr>
+            <a:r>
+              <a:rPr lang="en-US" sz="1400" dirty="0">
+                <a:solidFill>
+                  <a:schemeClr val="tx1"/>
+                </a:solidFill>
+              </a:rPr>
+              <a:t>Proposal: GitHub rule “1 approval required” (Paulin, 2 min)</a:t>
+            </a:r>
+            <a:endParaRPr lang="en-US" sz="1400" dirty="0"/>
+          </a:p>
+        </p:txBody>
+      </p:sp>
+      <p:sp>
+        <p:nvSpPr>
+          <p:cNvPr id="37" name="Lesson 1"/>
+          <p:cNvSpPr/>
+          <p:nvPr/>
+        </p:nvSpPr>
+        <p:spPr>
+          <a:xfrm>
+            <a:off x="4343400" y="3429000"/>
+            <a:ext cx="3520440" cy="2377440"/>
+          </a:xfrm>
+          <a:prstGeom prst="roundRect">
+            <a:avLst>
+              <a:gd name="adj" fmla="val 4615"/>
+            </a:avLst>
+          </a:prstGeom>
+          <a:solidFill>
+            <a:schemeClr val="bg2"/>
+          </a:solidFill>
+          <a:ln w="12700">
+            <a:solidFill>
+              <a:schemeClr val="bg2"/>
+            </a:solidFill>
+            <a:prstDash val="solid"/>
+          </a:ln>
+        </p:spPr>
+      </p:sp>
+      <p:sp>
+        <p:nvSpPr>
+          <p:cNvPr id="38" name="Lesson 1 dot"/>
+          <p:cNvSpPr/>
+          <p:nvPr/>
+        </p:nvSpPr>
+        <p:spPr>
+          <a:xfrm>
+            <a:off x="4572000" y="3675888"/>
+            <a:ext cx="182880" cy="182880"/>
+          </a:xfrm>
+          <a:prstGeom prst="ellipse">
+            <a:avLst/>
+          </a:prstGeom>
+          <a:solidFill>
+            <a:schemeClr val="accent2"/>
+          </a:solidFill>
+          <a:ln w="12700">
+            <a:solidFill>
+              <a:schemeClr val="accent2"/>
+            </a:solidFill>
+            <a:prstDash val="solid"/>
+          </a:ln>
+        </p:spPr>
+      </p:sp>
+      <p:sp>
+        <p:nvSpPr>
+          <p:cNvPr id="39" name="Lesson 1 title"/>
+          <p:cNvSpPr txBox="1"/>
+          <p:nvPr/>
+        </p:nvSpPr>
+        <p:spPr>
+          <a:xfrm>
+            <a:off x="4846320" y="3584448"/>
+            <a:ext cx="2834640" cy="365760"/>
+          </a:xfrm>
+          <a:prstGeom prst="rect">
+            <a:avLst/>
+          </a:prstGeom>
+          <a:noFill/>
+          <a:ln/>
+        </p:spPr>
+        <p:txBody>
+          <a:bodyPr wrap="square" lIns="0" tIns="0" rIns="0" bIns="0" rtlCol="0" anchor="ctr"/>
+          <a:lstStyle/>
+          <a:p>
+            <a:pPr indent="0" marL="0">
+              <a:buNone/>
+            </a:pPr>
+            <a:r>
+              <a:rPr lang="en-US" sz="1700" b="1" dirty="0">
+                <a:solidFill>
+                  <a:schemeClr val="tx2"/>
+                </a:solidFill>
+              </a:rPr>
+              <a:t>Re-run checks after merges</a:t>
+            </a:r>
+            <a:endParaRPr lang="en-US" sz="1700" dirty="0"/>
+          </a:p>
+        </p:txBody>
+      </p:sp>
+      <p:sp>
+        <p:nvSpPr>
+          <p:cNvPr id="40" name="Lesson body 1"/>
+          <p:cNvSpPr txBox="1"/>
+          <p:nvPr/>
+        </p:nvSpPr>
+        <p:spPr>
+          <a:xfrm>
+            <a:off x="4572000" y="4114800"/>
+            <a:ext cx="3108960" cy="1920240"/>
+          </a:xfrm>
+          <a:prstGeom prst="rect">
+            <a:avLst/>
+          </a:prstGeom>
+          <a:noFill/>
+          <a:ln/>
+        </p:spPr>
+        <p:txBody>
+          <a:bodyPr wrap="square" lIns="0" tIns="0" rIns="0" bIns="0" rtlCol="0" anchor="t"/>
+          <a:lstStyle/>
+          <a:p>
+            <a:pPr marL="177800" indent="-177800">
+              <a:spcAft>
+                <a:spcPts val="600"/>
+              </a:spcAft>
+              <a:buSzPct val="100000"/>
+              <a:buChar char="•"/>
+            </a:pPr>
+            <a:r>
+              <a:rPr lang="en-US" sz="1400" dirty="0">
+                <a:solidFill>
+                  <a:schemeClr val="tx1"/>
+                </a:solidFill>
+              </a:rPr>
+              <a:t>#5 and #6 were fine alone but clashed together: 1 check failed on main</a:t>
+            </a:r>
+            <a:endParaRPr lang="en-US" sz="1400" dirty="0"/>
+          </a:p>
+          <a:p>
+            <a:pPr marL="177800" indent="-177800">
+              <a:spcAft>
+                <a:spcPts val="600"/>
+              </a:spcAft>
+              <a:buSzPct val="100000"/>
+              <a:buChar char="•"/>
+            </a:pPr>
+            <a:r>
+              <a:rPr lang="en-US" sz="1400" dirty="0">
+                <a:solidFill>
+                  <a:schemeClr val="tx1"/>
+                </a:solidFill>
+              </a:rPr>
+              <a:t>Fixed by #7; now 35 checks pass on the PR #8 branch</a:t>
+            </a:r>
+            <a:endParaRPr lang="en-US" sz="1400" dirty="0"/>
+          </a:p>
+        </p:txBody>
+      </p:sp>
+      <p:sp>
+        <p:nvSpPr>
+          <p:cNvPr id="41" name="Lesson 2"/>
+          <p:cNvSpPr/>
+          <p:nvPr/>
+        </p:nvSpPr>
+        <p:spPr>
+          <a:xfrm>
+            <a:off x="8138160" y="3429000"/>
+            <a:ext cx="3520440" cy="2377440"/>
+          </a:xfrm>
+          <a:prstGeom prst="roundRect">
+            <a:avLst>
+              <a:gd name="adj" fmla="val 4615"/>
+            </a:avLst>
+          </a:prstGeom>
+          <a:solidFill>
+            <a:schemeClr val="bg2"/>
+          </a:solidFill>
+          <a:ln w="12700">
+            <a:solidFill>
+              <a:schemeClr val="bg2"/>
+            </a:solidFill>
+            <a:prstDash val="solid"/>
+          </a:ln>
+        </p:spPr>
+      </p:sp>
+      <p:sp>
+        <p:nvSpPr>
+          <p:cNvPr id="42" name="Lesson 2 dot"/>
+          <p:cNvSpPr/>
+          <p:nvPr/>
+        </p:nvSpPr>
+        <p:spPr>
+          <a:xfrm>
+            <a:off x="8366760" y="3675888"/>
+            <a:ext cx="182880" cy="182880"/>
+          </a:xfrm>
+          <a:prstGeom prst="ellipse">
+            <a:avLst/>
+          </a:prstGeom>
+          <a:solidFill>
+            <a:schemeClr val="accent1"/>
+          </a:solidFill>
+          <a:ln w="12700">
+            <a:solidFill>
+              <a:schemeClr val="accent1"/>
+            </a:solidFill>
+            <a:prstDash val="solid"/>
+          </a:ln>
+        </p:spPr>
+      </p:sp>
+      <p:sp>
+        <p:nvSpPr>
+          <p:cNvPr id="43" name="Lesson 2 title"/>
+          <p:cNvSpPr txBox="1"/>
+          <p:nvPr/>
+        </p:nvSpPr>
+        <p:spPr>
+          <a:xfrm>
+            <a:off x="8641080" y="3584448"/>
+            <a:ext cx="2834640" cy="365760"/>
+          </a:xfrm>
+          <a:prstGeom prst="rect">
+            <a:avLst/>
+          </a:prstGeom>
+          <a:noFill/>
+          <a:ln/>
+        </p:spPr>
+        <p:txBody>
+          <a:bodyPr wrap="square" lIns="0" tIns="0" rIns="0" bIns="0" rtlCol="0" anchor="ctr"/>
+          <a:lstStyle/>
+          <a:p>
+            <a:pPr indent="0" marL="0">
+              <a:buNone/>
+            </a:pPr>
+            <a:r>
+              <a:rPr lang="en-US" sz="1700" b="1" dirty="0">
+                <a:solidFill>
+                  <a:schemeClr val="tx2"/>
+                </a:solidFill>
+              </a:rPr>
+              <a:t>Keep the repo tidy</a:t>
+            </a:r>
+            <a:endParaRPr lang="en-US" sz="1700" dirty="0"/>
+          </a:p>
+        </p:txBody>
+      </p:sp>
+      <p:sp>
+        <p:nvSpPr>
+          <p:cNvPr id="44" name="Lesson body 2"/>
+          <p:cNvSpPr txBox="1"/>
+          <p:nvPr/>
+        </p:nvSpPr>
+        <p:spPr>
+          <a:xfrm>
+            <a:off x="8366760" y="4114800"/>
+            <a:ext cx="3108960" cy="1920240"/>
+          </a:xfrm>
+          <a:prstGeom prst="rect">
+            <a:avLst/>
+          </a:prstGeom>
+          <a:noFill/>
+          <a:ln/>
+        </p:spPr>
+        <p:txBody>
+          <a:bodyPr wrap="square" lIns="0" tIns="0" rIns="0" bIns="0" rtlCol="0" anchor="t"/>
+          <a:lstStyle/>
+          <a:p>
+            <a:pPr marL="177800" indent="-177800">
+              <a:spcAft>
+                <a:spcPts val="600"/>
+              </a:spcAft>
+              <a:buSzPct val="100000"/>
+              <a:buChar char="•"/>
+            </a:pPr>
+            <a:r>
+              <a:rPr lang="en-US" sz="1400" dirty="0">
+                <a:solidFill>
+                  <a:schemeClr val="tx1"/>
+                </a:solidFill>
+              </a:rPr>
+              <a:t>5 finished branches deleted</a:t>
+            </a:r>
+            <a:endParaRPr lang="en-US" sz="1400" dirty="0"/>
+          </a:p>
+          <a:p>
+            <a:pPr marL="177800" indent="-177800">
+              <a:spcAft>
+                <a:spcPts val="600"/>
+              </a:spcAft>
+              <a:buSzPct val="100000"/>
+              <a:buChar char="•"/>
+            </a:pPr>
+            <a:r>
+              <a:rPr lang="en-US" sz="1400" dirty="0">
+                <a:solidFill>
+                  <a:schemeClr val="tx1"/>
+                </a:solidFill>
+              </a:rPr>
+              <a:t>Tick “Automatically delete head branches” in Settings</a:t>
+            </a:r>
+            <a:endParaRPr lang="en-US" sz="1400" dirty="0"/>
+          </a:p>
+        </p:txBody>
+      </p:sp>
+      <p:sp>
+        <p:nvSpPr>
+          <p:cNvPr id="45" name="Work footnote"/>
+          <p:cNvSpPr txBox="1"/>
+          <p:nvPr/>
+        </p:nvSpPr>
+        <p:spPr>
+          <a:xfrm>
+            <a:off x="548640" y="6400800"/>
+            <a:ext cx="11064240" cy="274320"/>
+          </a:xfrm>
+          <a:prstGeom prst="rect">
+            <a:avLst/>
+          </a:prstGeom>
+          <a:noFill/>
+          <a:ln/>
+        </p:spPr>
+        <p:txBody>
+          <a:bodyPr wrap="square" lIns="0" tIns="0" rIns="0" bIns="0" rtlCol="0" anchor="ctr"/>
+          <a:lstStyle/>
+          <a:p>
+            <a:pPr indent="0" marL="0">
+              <a:buNone/>
+            </a:pPr>
+            <a:r>
+              <a:rPr lang="en-US" sz="1000" dirty="0">
+                <a:solidFill>
+                  <a:schemeClr val="accent6"/>
+                </a:solidFill>
+              </a:rPr>
+              <a:t>Open branches today: main, feat/dense-hybrid (PR #8), README_update (Léopold, no PR yet).</a:t>
+            </a:r>
+            <a:endParaRPr lang="en-US" sz="1000" dirty="0"/>
+          </a:p>
+        </p:txBody>
+      </p:sp>
+    </p:spTree>
+  </p:cSld>
+  <p:clrMapOvr>
+    <a:masterClrMapping/>
+  </p:clrMapOvr>
+</p:sld>
+</file>
+
+<file path=ppt/slides/slide15.xml><?xml version="1.0" encoding="utf-8"?>
+<p:sld xmlns:a="http://schemas.openxmlformats.org/drawingml/2006/main" xmlns:r="http://schemas.openxmlformats.org/officeDocument/2006/relationships" xmlns:p="http://schemas.openxmlformats.org/presentationml/2006/main">
+  <p:cSld name="Slide 15">
+    <p:spTree>
+      <p:nvGrpSpPr>
+        <p:cNvPr id="1" name=""/>
+        <p:cNvGrpSpPr/>
+        <p:nvPr/>
+      </p:nvGrpSpPr>
+      <p:grpSpPr>
+        <a:xfrm>
+          <a:off x="0" y="0"/>
+          <a:ext cx="0" cy="0"/>
+          <a:chOff x="0" y="0"/>
+          <a:chExt cx="0" cy="0"/>
+        </a:xfrm>
+      </p:grpSpPr>
+      <p:sp>
+        <p:nvSpPr>
+          <p:cNvPr id="2" name="Text 0"/>
+          <p:cNvSpPr/>
+          <p:nvPr>
+            <p:ph idx="100" type="title" hasCustomPrompt="1"/>
+          </p:nvPr>
+        </p:nvSpPr>
+        <p:spPr>
+          <a:xfrm>
+            <a:off x="548640" y="320040"/>
+            <a:ext cx="9144000" cy="685800"/>
+          </a:xfrm>
+          <a:prstGeom prst="rect">
+            <a:avLst/>
+          </a:prstGeom>
+          <a:noFill/>
+          <a:ln/>
+        </p:spPr>
+        <p:txBody>
+          <a:bodyPr wrap="square" lIns="0" tIns="0" rIns="0" bIns="0" rtlCol="0" anchor="ctr"/>
+          <a:lstStyle/>
+          <a:p>
+            <a:pPr algn="l" indent="0" marL="0">
+              <a:buNone/>
+            </a:pPr>
+            <a:r>
+              <a:rPr lang="en-US" sz="3000" b="1" dirty="0">
+                <a:solidFill>
+                  <a:schemeClr val="tx2"/>
+                </a:solidFill>
+              </a:rPr>
               <a:t>Next 5 days: who does what (to fill in today)</a:t>
             </a:r>
             <a:endParaRPr lang="en-US" sz="3000" dirty="0"/>
@@ -12123,7 +13383,7 @@
       </p:sp>
       <p:graphicFrame>
         <p:nvGraphicFramePr>
-          <p:cNvPr id="15" name="Plan table"/>
+          <p:cNvPr id="16" name="Plan table"/>
           <p:cNvGraphicFramePr>
             <a:graphicFrameLocks noGrp="1"/>
           </p:cNvGraphicFramePr>
@@ -12471,7 +13731,7 @@
                             <a:schemeClr val="tx1"/>
                           </a:solidFill>
                         </a:rPr>
-                        <a:t>Reranker benchmark; review and merge PR #8</a:t>
+                        <a:t>Review and merge PR #8 (meaning search + ranking)</a:t>
                       </a:r>
                       <a:endParaRPr lang="en-US" sz="1300" dirty="0"/>
                     </a:p>
@@ -12532,7 +13792,7 @@
                             <a:schemeClr val="tx1"/>
                           </a:solidFill>
                         </a:rPr>
-                        <a:t>Reranker restores rank 1 above bge-m3 alone</a:t>
+                        <a:t>35 checks pass on main</a:t>
                       </a:r>
                       <a:endParaRPr lang="en-US" sz="1300" dirty="0"/>
                     </a:p>

</xml_diff>